<commit_message>
Bigger fonts throughout the Writing Business Reports deck
</commit_message>
<xml_diff>
--- a/public/downloads/US8252-Writing-Business-Reports.pptx
+++ b/public/downloads/US8252-Writing-Business-Reports.pptx
@@ -3261,8 +3261,8 @@
         </p:nvSpPr>
         <p:spPr>
           <a:xfrm>
-            <a:off x="502920" y="274320"/>
-            <a:ext cx="11183112" cy="329184"/>
+            <a:off x="502920" y="256032"/>
+            <a:ext cx="11183112" cy="347472"/>
           </a:xfrm>
           <a:prstGeom prst="rect">
             <a:avLst/>
@@ -3278,7 +3278,7 @@
               <a:buNone/>
             </a:pPr>
             <a:r>
-              <a:rPr lang="en-US" sz="1300" b="1" spc="200" kern="0" dirty="0">
+              <a:rPr lang="en-US" sz="1400" b="1" spc="200" kern="0" dirty="0">
                 <a:solidFill>
                   <a:srgbClr val="0F6CBD"/>
                 </a:solidFill>
@@ -3288,7 +3288,7 @@
               </a:rPr>
               <a:t>REPORT STRUCTURE</a:t>
             </a:r>
-            <a:endParaRPr lang="en-US" sz="1300" dirty="0"/>
+            <a:endParaRPr lang="en-US" sz="1400" dirty="0"/>
           </a:p>
         </p:txBody>
       </p:sp>
@@ -3300,8 +3300,8 @@
         </p:nvSpPr>
         <p:spPr>
           <a:xfrm>
-            <a:off x="502920" y="603504"/>
-            <a:ext cx="11183112" cy="749808"/>
+            <a:off x="502920" y="585216"/>
+            <a:ext cx="11183112" cy="786384"/>
           </a:xfrm>
           <a:prstGeom prst="rect">
             <a:avLst/>
@@ -3317,7 +3317,7 @@
               <a:buNone/>
             </a:pPr>
             <a:r>
-              <a:rPr lang="en-US" sz="3100" b="1" dirty="0">
+              <a:rPr lang="en-US" sz="3400" b="1" dirty="0">
                 <a:solidFill>
                   <a:srgbClr val="002050"/>
                 </a:solidFill>
@@ -3327,7 +3327,7 @@
               </a:rPr>
               <a:t>What is the Basic Structure of a Report?</a:t>
             </a:r>
-            <a:endParaRPr lang="en-US" sz="3100" dirty="0"/>
+            <a:endParaRPr lang="en-US" sz="3400" dirty="0"/>
           </a:p>
         </p:txBody>
       </p:sp>
@@ -3362,7 +3362,7 @@
               <a:buNone/>
             </a:pPr>
             <a:r>
-              <a:rPr lang="en-US" sz="1750" dirty="0">
+              <a:rPr lang="en-US" sz="2000" dirty="0">
                 <a:solidFill>
                   <a:srgbClr val="002050"/>
                 </a:solidFill>
@@ -3373,7 +3373,7 @@
               <a:t>Types of reports can vary greatly; they can range from an experimental report to an environmental impact statement. There is, however, a basic structure common to most reports, irrespective of their type.
 </a:t>
             </a:r>
-            <a:endParaRPr lang="en-US" sz="1750" dirty="0"/>
+            <a:endParaRPr lang="en-US" sz="2000" dirty="0"/>
           </a:p>
           <a:p>
             <a:pPr indent="0" marL="0">
@@ -3386,7 +3386,7 @@
               <a:buNone/>
             </a:pPr>
             <a:r>
-              <a:rPr lang="en-US" sz="1750" dirty="0">
+              <a:rPr lang="en-US" sz="2000" dirty="0">
                 <a:solidFill>
                   <a:srgbClr val="002050"/>
                 </a:solidFill>
@@ -3396,7 +3396,7 @@
               </a:rPr>
               <a:t>The major components of a general report are shown on the next slide — from the title page through to the appendices.</a:t>
             </a:r>
-            <a:endParaRPr lang="en-US" sz="1750" dirty="0"/>
+            <a:endParaRPr lang="en-US" sz="2000" dirty="0"/>
           </a:p>
         </p:txBody>
       </p:sp>
@@ -3568,8 +3568,8 @@
         </p:nvSpPr>
         <p:spPr>
           <a:xfrm>
-            <a:off x="502920" y="274320"/>
-            <a:ext cx="11183112" cy="329184"/>
+            <a:off x="502920" y="256032"/>
+            <a:ext cx="11183112" cy="347472"/>
           </a:xfrm>
           <a:prstGeom prst="rect">
             <a:avLst/>
@@ -3585,7 +3585,7 @@
               <a:buNone/>
             </a:pPr>
             <a:r>
-              <a:rPr lang="en-US" sz="1300" b="1" spc="200" kern="0" dirty="0">
+              <a:rPr lang="en-US" sz="1400" b="1" spc="200" kern="0" dirty="0">
                 <a:solidFill>
                   <a:srgbClr val="0F6CBD"/>
                 </a:solidFill>
@@ -3595,7 +3595,7 @@
               </a:rPr>
               <a:t>REPORT STRUCTURE</a:t>
             </a:r>
-            <a:endParaRPr lang="en-US" sz="1300" dirty="0"/>
+            <a:endParaRPr lang="en-US" sz="1400" dirty="0"/>
           </a:p>
         </p:txBody>
       </p:sp>
@@ -3607,8 +3607,8 @@
         </p:nvSpPr>
         <p:spPr>
           <a:xfrm>
-            <a:off x="502920" y="603504"/>
-            <a:ext cx="11183112" cy="749808"/>
+            <a:off x="502920" y="585216"/>
+            <a:ext cx="11183112" cy="786384"/>
           </a:xfrm>
           <a:prstGeom prst="rect">
             <a:avLst/>
@@ -3624,7 +3624,7 @@
               <a:buNone/>
             </a:pPr>
             <a:r>
-              <a:rPr lang="en-US" sz="3100" b="1" dirty="0">
+              <a:rPr lang="en-US" sz="3400" b="1" dirty="0">
                 <a:solidFill>
                   <a:srgbClr val="002050"/>
                 </a:solidFill>
@@ -3634,7 +3634,7 @@
               </a:rPr>
               <a:t>Major Components of a General Report</a:t>
             </a:r>
-            <a:endParaRPr lang="en-US" sz="3100" dirty="0"/>
+            <a:endParaRPr lang="en-US" sz="3400" dirty="0"/>
           </a:p>
         </p:txBody>
       </p:sp>
@@ -3653,7 +3653,7 @@
           </p:nvPr>
         </p:nvGraphicFramePr>
         <p:xfrm>
-          <a:off x="502920" y="1554480"/>
+          <a:off x="502920" y="1481328"/>
           <a:ext cx="11183112" cy="914400"/>
         </p:xfrm>
         <a:graphic>
@@ -3664,7 +3664,7 @@
                 <a:gridCol w="2651760"/>
                 <a:gridCol w="8531352"/>
               </a:tblGrid>
-              <a:tr h="475488">
+              <a:tr h="512064">
                 <a:tc>
                   <a:txBody>
                     <a:bodyPr/>
@@ -3674,7 +3674,7 @@
                         <a:buNone/>
                       </a:pPr>
                       <a:r>
-                        <a:rPr lang="en-US" sz="1250" b="1" dirty="0">
+                        <a:rPr lang="en-US" sz="1350" b="1" dirty="0">
                           <a:solidFill>
                             <a:srgbClr val="FFFFFF"/>
                           </a:solidFill>
@@ -3684,7 +3684,7 @@
                         </a:rPr>
                         <a:t>Component</a:t>
                       </a:r>
-                      <a:endParaRPr lang="en-US" sz="1250" dirty="0">
+                      <a:endParaRPr lang="en-US" sz="1350" dirty="0">
                         <a:latin typeface="Aptos Display" charset="0"/>
                         <a:ea typeface="Aptos Display" charset="0"/>
                         <a:cs typeface="Aptos Display" charset="0"/>
@@ -3742,7 +3742,7 @@
                         <a:buNone/>
                       </a:pPr>
                       <a:r>
-                        <a:rPr lang="en-US" sz="1250" b="1" dirty="0">
+                        <a:rPr lang="en-US" sz="1350" b="1" dirty="0">
                           <a:solidFill>
                             <a:srgbClr val="FFFFFF"/>
                           </a:solidFill>
@@ -3752,7 +3752,7 @@
                         </a:rPr>
                         <a:t>What it contains</a:t>
                       </a:r>
-                      <a:endParaRPr lang="en-US" sz="1250" dirty="0">
+                      <a:endParaRPr lang="en-US" sz="1350" dirty="0">
                         <a:latin typeface="Aptos Display" charset="0"/>
                         <a:ea typeface="Aptos Display" charset="0"/>
                         <a:cs typeface="Aptos Display" charset="0"/>
@@ -3802,7 +3802,7 @@
                   </a:tcPr>
                 </a:tc>
               </a:tr>
-              <a:tr h="475488">
+              <a:tr h="512064">
                 <a:tc>
                   <a:txBody>
                     <a:bodyPr/>
@@ -3812,7 +3812,7 @@
                         <a:buNone/>
                       </a:pPr>
                       <a:r>
-                        <a:rPr lang="en-US" sz="1250" dirty="0">
+                        <a:rPr lang="en-US" sz="1350" dirty="0">
                           <a:solidFill>
                             <a:srgbClr val="002050"/>
                           </a:solidFill>
@@ -3822,7 +3822,7 @@
                         </a:rPr>
                         <a:t>Title Page</a:t>
                       </a:r>
-                      <a:endParaRPr lang="en-US" sz="1250" dirty="0">
+                      <a:endParaRPr lang="en-US" sz="1350" dirty="0">
                         <a:latin typeface="Aptos" charset="0"/>
                         <a:ea typeface="Aptos" charset="0"/>
                         <a:cs typeface="Aptos" charset="0"/>
@@ -3880,7 +3880,7 @@
                         <a:buNone/>
                       </a:pPr>
                       <a:r>
-                        <a:rPr lang="en-US" sz="1250" dirty="0">
+                        <a:rPr lang="en-US" sz="1350" dirty="0">
                           <a:solidFill>
                             <a:srgbClr val="002050"/>
                           </a:solidFill>
@@ -3890,7 +3890,7 @@
                         </a:rPr>
                         <a:t>The report title, and identifying details</a:t>
                       </a:r>
-                      <a:endParaRPr lang="en-US" sz="1250" dirty="0">
+                      <a:endParaRPr lang="en-US" sz="1350" dirty="0">
                         <a:latin typeface="Aptos" charset="0"/>
                         <a:ea typeface="Aptos" charset="0"/>
                         <a:cs typeface="Aptos" charset="0"/>
@@ -3940,7 +3940,7 @@
                   </a:tcPr>
                 </a:tc>
               </a:tr>
-              <a:tr h="475488">
+              <a:tr h="512064">
                 <a:tc>
                   <a:txBody>
                     <a:bodyPr/>
@@ -3950,7 +3950,7 @@
                         <a:buNone/>
                       </a:pPr>
                       <a:r>
-                        <a:rPr lang="en-US" sz="1250" dirty="0">
+                        <a:rPr lang="en-US" sz="1350" dirty="0">
                           <a:solidFill>
                             <a:srgbClr val="002050"/>
                           </a:solidFill>
@@ -3960,7 +3960,7 @@
                         </a:rPr>
                         <a:t>Abstract</a:t>
                       </a:r>
-                      <a:endParaRPr lang="en-US" sz="1250" dirty="0">
+                      <a:endParaRPr lang="en-US" sz="1350" dirty="0">
                         <a:latin typeface="Aptos" charset="0"/>
                         <a:ea typeface="Aptos" charset="0"/>
                         <a:cs typeface="Aptos" charset="0"/>
@@ -4018,7 +4018,7 @@
                         <a:buNone/>
                       </a:pPr>
                       <a:r>
-                        <a:rPr lang="en-US" sz="1250" dirty="0">
+                        <a:rPr lang="en-US" sz="1350" dirty="0">
                           <a:solidFill>
                             <a:srgbClr val="002050"/>
                           </a:solidFill>
@@ -4028,7 +4028,7 @@
                         </a:rPr>
                         <a:t>In less than 200 words: what was the problem, how was it investigated, what did you find out and what do your findings mean?</a:t>
                       </a:r>
-                      <a:endParaRPr lang="en-US" sz="1250" dirty="0">
+                      <a:endParaRPr lang="en-US" sz="1350" dirty="0">
                         <a:latin typeface="Aptos" charset="0"/>
                         <a:ea typeface="Aptos" charset="0"/>
                         <a:cs typeface="Aptos" charset="0"/>
@@ -4078,7 +4078,7 @@
                   </a:tcPr>
                 </a:tc>
               </a:tr>
-              <a:tr h="475488">
+              <a:tr h="512064">
                 <a:tc>
                   <a:txBody>
                     <a:bodyPr/>
@@ -4088,7 +4088,7 @@
                         <a:buNone/>
                       </a:pPr>
                       <a:r>
-                        <a:rPr lang="en-US" sz="1250" dirty="0">
+                        <a:rPr lang="en-US" sz="1350" dirty="0">
                           <a:solidFill>
                             <a:srgbClr val="002050"/>
                           </a:solidFill>
@@ -4098,7 +4098,7 @@
                         </a:rPr>
                         <a:t>Table of Contents</a:t>
                       </a:r>
-                      <a:endParaRPr lang="en-US" sz="1250" dirty="0">
+                      <a:endParaRPr lang="en-US" sz="1350" dirty="0">
                         <a:latin typeface="Aptos" charset="0"/>
                         <a:ea typeface="Aptos" charset="0"/>
                         <a:cs typeface="Aptos" charset="0"/>
@@ -4156,7 +4156,7 @@
                         <a:buNone/>
                       </a:pPr>
                       <a:r>
-                        <a:rPr lang="en-US" sz="1250" dirty="0">
+                        <a:rPr lang="en-US" sz="1350" dirty="0">
                           <a:solidFill>
                             <a:srgbClr val="002050"/>
                           </a:solidFill>
@@ -4166,7 +4166,7 @@
                         </a:rPr>
                         <a:t>A list of the major and minor sections of your report</a:t>
                       </a:r>
-                      <a:endParaRPr lang="en-US" sz="1250" dirty="0">
+                      <a:endParaRPr lang="en-US" sz="1350" dirty="0">
                         <a:latin typeface="Aptos" charset="0"/>
                         <a:ea typeface="Aptos" charset="0"/>
                         <a:cs typeface="Aptos" charset="0"/>
@@ -4216,7 +4216,7 @@
                   </a:tcPr>
                 </a:tc>
               </a:tr>
-              <a:tr h="475488">
+              <a:tr h="512064">
                 <a:tc>
                   <a:txBody>
                     <a:bodyPr/>
@@ -4226,7 +4226,7 @@
                         <a:buNone/>
                       </a:pPr>
                       <a:r>
-                        <a:rPr lang="en-US" sz="1250" dirty="0">
+                        <a:rPr lang="en-US" sz="1350" dirty="0">
                           <a:solidFill>
                             <a:srgbClr val="002050"/>
                           </a:solidFill>
@@ -4236,7 +4236,7 @@
                         </a:rPr>
                         <a:t>Introduction</a:t>
                       </a:r>
-                      <a:endParaRPr lang="en-US" sz="1250" dirty="0">
+                      <a:endParaRPr lang="en-US" sz="1350" dirty="0">
                         <a:latin typeface="Aptos" charset="0"/>
                         <a:ea typeface="Aptos" charset="0"/>
                         <a:cs typeface="Aptos" charset="0"/>
@@ -4294,7 +4294,7 @@
                         <a:buNone/>
                       </a:pPr>
                       <a:r>
-                        <a:rPr lang="en-US" sz="1250" dirty="0">
+                        <a:rPr lang="en-US" sz="1350" dirty="0">
                           <a:solidFill>
                             <a:srgbClr val="002050"/>
                           </a:solidFill>
@@ -4304,7 +4304,7 @@
                         </a:rPr>
                         <a:t>Set the scene; give background about the topic; state the aim/purpose of the investigation; outline the body sections</a:t>
                       </a:r>
-                      <a:endParaRPr lang="en-US" sz="1250" dirty="0">
+                      <a:endParaRPr lang="en-US" sz="1350" dirty="0">
                         <a:latin typeface="Aptos" charset="0"/>
                         <a:ea typeface="Aptos" charset="0"/>
                         <a:cs typeface="Aptos" charset="0"/>
@@ -4354,7 +4354,7 @@
                   </a:tcPr>
                 </a:tc>
               </a:tr>
-              <a:tr h="475488">
+              <a:tr h="512064">
                 <a:tc>
                   <a:txBody>
                     <a:bodyPr/>
@@ -4364,7 +4364,7 @@
                         <a:buNone/>
                       </a:pPr>
                       <a:r>
-                        <a:rPr lang="en-US" sz="1250" dirty="0">
+                        <a:rPr lang="en-US" sz="1350" dirty="0">
                           <a:solidFill>
                             <a:srgbClr val="002050"/>
                           </a:solidFill>
@@ -4374,7 +4374,7 @@
                         </a:rPr>
                         <a:t>Main Body</a:t>
                       </a:r>
-                      <a:endParaRPr lang="en-US" sz="1250" dirty="0">
+                      <a:endParaRPr lang="en-US" sz="1350" dirty="0">
                         <a:latin typeface="Aptos" charset="0"/>
                         <a:ea typeface="Aptos" charset="0"/>
                         <a:cs typeface="Aptos" charset="0"/>
@@ -4432,7 +4432,7 @@
                         <a:buNone/>
                       </a:pPr>
                       <a:r>
-                        <a:rPr lang="en-US" sz="1250" dirty="0">
+                        <a:rPr lang="en-US" sz="1350" dirty="0">
                           <a:solidFill>
                             <a:srgbClr val="002050"/>
                           </a:solidFill>
@@ -4442,7 +4442,7 @@
                         </a:rPr>
                         <a:t>Organise sections in a logical sequence: what you investigated, what you found, what interpretations and judgments you made. Use short informative headings and subheadings</a:t>
                       </a:r>
-                      <a:endParaRPr lang="en-US" sz="1250" dirty="0">
+                      <a:endParaRPr lang="en-US" sz="1350" dirty="0">
                         <a:latin typeface="Aptos" charset="0"/>
                         <a:ea typeface="Aptos" charset="0"/>
                         <a:cs typeface="Aptos" charset="0"/>
@@ -4492,7 +4492,7 @@
                   </a:tcPr>
                 </a:tc>
               </a:tr>
-              <a:tr h="475488">
+              <a:tr h="512064">
                 <a:tc>
                   <a:txBody>
                     <a:bodyPr/>
@@ -4502,7 +4502,7 @@
                         <a:buNone/>
                       </a:pPr>
                       <a:r>
-                        <a:rPr lang="en-US" sz="1250" dirty="0">
+                        <a:rPr lang="en-US" sz="1350" dirty="0">
                           <a:solidFill>
                             <a:srgbClr val="002050"/>
                           </a:solidFill>
@@ -4512,7 +4512,7 @@
                         </a:rPr>
                         <a:t>Conclusion</a:t>
                       </a:r>
-                      <a:endParaRPr lang="en-US" sz="1250" dirty="0">
+                      <a:endParaRPr lang="en-US" sz="1350" dirty="0">
                         <a:latin typeface="Aptos" charset="0"/>
                         <a:ea typeface="Aptos" charset="0"/>
                         <a:cs typeface="Aptos" charset="0"/>
@@ -4570,7 +4570,7 @@
                         <a:buNone/>
                       </a:pPr>
                       <a:r>
-                        <a:rPr lang="en-US" sz="1250" dirty="0">
+                        <a:rPr lang="en-US" sz="1350" dirty="0">
                           <a:solidFill>
                             <a:srgbClr val="002050"/>
                           </a:solidFill>
@@ -4580,7 +4580,7 @@
                         </a:rPr>
                         <a:t>What has been achieved and the significance of your findings and discussion? Have your aims been successful or not?</a:t>
                       </a:r>
-                      <a:endParaRPr lang="en-US" sz="1250" dirty="0">
+                      <a:endParaRPr lang="en-US" sz="1350" dirty="0">
                         <a:latin typeface="Aptos" charset="0"/>
                         <a:ea typeface="Aptos" charset="0"/>
                         <a:cs typeface="Aptos" charset="0"/>
@@ -4630,7 +4630,7 @@
                   </a:tcPr>
                 </a:tc>
               </a:tr>
-              <a:tr h="475488">
+              <a:tr h="512064">
                 <a:tc>
                   <a:txBody>
                     <a:bodyPr/>
@@ -4640,7 +4640,7 @@
                         <a:buNone/>
                       </a:pPr>
                       <a:r>
-                        <a:rPr lang="en-US" sz="1250" dirty="0">
+                        <a:rPr lang="en-US" sz="1350" dirty="0">
                           <a:solidFill>
                             <a:srgbClr val="002050"/>
                           </a:solidFill>
@@ -4650,7 +4650,7 @@
                         </a:rPr>
                         <a:t>Recommendations</a:t>
                       </a:r>
-                      <a:endParaRPr lang="en-US" sz="1250" dirty="0">
+                      <a:endParaRPr lang="en-US" sz="1350" dirty="0">
                         <a:latin typeface="Aptos" charset="0"/>
                         <a:ea typeface="Aptos" charset="0"/>
                         <a:cs typeface="Aptos" charset="0"/>
@@ -4708,7 +4708,7 @@
                         <a:buNone/>
                       </a:pPr>
                       <a:r>
-                        <a:rPr lang="en-US" sz="1250" dirty="0">
+                        <a:rPr lang="en-US" sz="1350" dirty="0">
                           <a:solidFill>
                             <a:srgbClr val="002050"/>
                           </a:solidFill>
@@ -4718,7 +4718,7 @@
                         </a:rPr>
                         <a:t>What do you recommend as a course of action following your conclusion?</a:t>
                       </a:r>
-                      <a:endParaRPr lang="en-US" sz="1250" dirty="0">
+                      <a:endParaRPr lang="en-US" sz="1350" dirty="0">
                         <a:latin typeface="Aptos" charset="0"/>
                         <a:ea typeface="Aptos" charset="0"/>
                         <a:cs typeface="Aptos" charset="0"/>
@@ -4768,7 +4768,7 @@
                   </a:tcPr>
                 </a:tc>
               </a:tr>
-              <a:tr h="475488">
+              <a:tr h="512064">
                 <a:tc>
                   <a:txBody>
                     <a:bodyPr/>
@@ -4778,7 +4778,7 @@
                         <a:buNone/>
                       </a:pPr>
                       <a:r>
-                        <a:rPr lang="en-US" sz="1250" dirty="0">
+                        <a:rPr lang="en-US" sz="1350" dirty="0">
                           <a:solidFill>
                             <a:srgbClr val="002050"/>
                           </a:solidFill>
@@ -4788,7 +4788,7 @@
                         </a:rPr>
                         <a:t>References</a:t>
                       </a:r>
-                      <a:endParaRPr lang="en-US" sz="1250" dirty="0">
+                      <a:endParaRPr lang="en-US" sz="1350" dirty="0">
                         <a:latin typeface="Aptos" charset="0"/>
                         <a:ea typeface="Aptos" charset="0"/>
                         <a:cs typeface="Aptos" charset="0"/>
@@ -4846,7 +4846,7 @@
                         <a:buNone/>
                       </a:pPr>
                       <a:r>
-                        <a:rPr lang="en-US" sz="1250" dirty="0">
+                        <a:rPr lang="en-US" sz="1350" dirty="0">
                           <a:solidFill>
                             <a:srgbClr val="002050"/>
                           </a:solidFill>
@@ -4856,7 +4856,7 @@
                         </a:rPr>
                         <a:t>A list of all the sources you used</a:t>
                       </a:r>
-                      <a:endParaRPr lang="en-US" sz="1250" dirty="0">
+                      <a:endParaRPr lang="en-US" sz="1350" dirty="0">
                         <a:latin typeface="Aptos" charset="0"/>
                         <a:ea typeface="Aptos" charset="0"/>
                         <a:cs typeface="Aptos" charset="0"/>
@@ -4906,7 +4906,7 @@
                   </a:tcPr>
                 </a:tc>
               </a:tr>
-              <a:tr h="475488">
+              <a:tr h="512064">
                 <a:tc>
                   <a:txBody>
                     <a:bodyPr/>
@@ -4916,7 +4916,7 @@
                         <a:buNone/>
                       </a:pPr>
                       <a:r>
-                        <a:rPr lang="en-US" sz="1250" dirty="0">
+                        <a:rPr lang="en-US" sz="1350" dirty="0">
                           <a:solidFill>
                             <a:srgbClr val="002050"/>
                           </a:solidFill>
@@ -4926,7 +4926,7 @@
                         </a:rPr>
                         <a:t>Appendices</a:t>
                       </a:r>
-                      <a:endParaRPr lang="en-US" sz="1250" dirty="0">
+                      <a:endParaRPr lang="en-US" sz="1350" dirty="0">
                         <a:latin typeface="Aptos" charset="0"/>
                         <a:ea typeface="Aptos" charset="0"/>
                         <a:cs typeface="Aptos" charset="0"/>
@@ -4984,7 +4984,7 @@
                         <a:buNone/>
                       </a:pPr>
                       <a:r>
-                        <a:rPr lang="en-US" sz="1250" dirty="0">
+                        <a:rPr lang="en-US" sz="1350" dirty="0">
                           <a:solidFill>
                             <a:srgbClr val="002050"/>
                           </a:solidFill>
@@ -4994,7 +4994,7 @@
                         </a:rPr>
                         <a:t>Any information (graphs, charts, tables or other data) used but not included in the body</a:t>
                       </a:r>
-                      <a:endParaRPr lang="en-US" sz="1250" dirty="0">
+                      <a:endParaRPr lang="en-US" sz="1350" dirty="0">
                         <a:latin typeface="Aptos" charset="0"/>
                         <a:ea typeface="Aptos" charset="0"/>
                         <a:cs typeface="Aptos" charset="0"/>
@@ -5186,8 +5186,8 @@
         </p:nvSpPr>
         <p:spPr>
           <a:xfrm>
-            <a:off x="502920" y="274320"/>
-            <a:ext cx="11183112" cy="329184"/>
+            <a:off x="502920" y="256032"/>
+            <a:ext cx="11183112" cy="347472"/>
           </a:xfrm>
           <a:prstGeom prst="rect">
             <a:avLst/>
@@ -5203,7 +5203,7 @@
               <a:buNone/>
             </a:pPr>
             <a:r>
-              <a:rPr lang="en-US" sz="1300" b="1" spc="200" kern="0" dirty="0">
+              <a:rPr lang="en-US" sz="1400" b="1" spc="200" kern="0" dirty="0">
                 <a:solidFill>
                   <a:srgbClr val="0F6CBD"/>
                 </a:solidFill>
@@ -5213,7 +5213,7 @@
               </a:rPr>
               <a:t>PURPOSE &amp; CONTENT OF REPORTS</a:t>
             </a:r>
-            <a:endParaRPr lang="en-US" sz="1300" dirty="0"/>
+            <a:endParaRPr lang="en-US" sz="1400" dirty="0"/>
           </a:p>
         </p:txBody>
       </p:sp>
@@ -5225,8 +5225,8 @@
         </p:nvSpPr>
         <p:spPr>
           <a:xfrm>
-            <a:off x="502920" y="603504"/>
-            <a:ext cx="11183112" cy="749808"/>
+            <a:off x="502920" y="585216"/>
+            <a:ext cx="11183112" cy="786384"/>
           </a:xfrm>
           <a:prstGeom prst="rect">
             <a:avLst/>
@@ -5242,7 +5242,7 @@
               <a:buNone/>
             </a:pPr>
             <a:r>
-              <a:rPr lang="en-US" sz="3100" b="1" dirty="0">
+              <a:rPr lang="en-US" sz="3400" b="1" dirty="0">
                 <a:solidFill>
                   <a:srgbClr val="002050"/>
                 </a:solidFill>
@@ -5252,7 +5252,7 @@
               </a:rPr>
               <a:t>There Are Various Types of Reports</a:t>
             </a:r>
-            <a:endParaRPr lang="en-US" sz="3100" dirty="0"/>
+            <a:endParaRPr lang="en-US" sz="3400" dirty="0"/>
           </a:p>
         </p:txBody>
       </p:sp>
@@ -5288,7 +5288,7 @@
               <a:buChar char="•"/>
             </a:pPr>
             <a:r>
-              <a:rPr lang="en-US" sz="1650" dirty="0">
+              <a:rPr lang="en-US" sz="1850" dirty="0">
                 <a:solidFill>
                   <a:srgbClr val="002050"/>
                 </a:solidFill>
@@ -5298,7 +5298,7 @@
               </a:rPr>
               <a:t>A report of a sports match</a:t>
             </a:r>
-            <a:endParaRPr lang="en-US" sz="1650" dirty="0"/>
+            <a:endParaRPr lang="en-US" sz="1850" dirty="0"/>
           </a:p>
           <a:p>
             <a:pPr marL="228600" indent="-228600">
@@ -5312,7 +5312,7 @@
               <a:buChar char="•"/>
             </a:pPr>
             <a:r>
-              <a:rPr lang="en-US" sz="1650" dirty="0">
+              <a:rPr lang="en-US" sz="1850" dirty="0">
                 <a:solidFill>
                   <a:srgbClr val="002050"/>
                 </a:solidFill>
@@ -5322,7 +5322,7 @@
               </a:rPr>
               <a:t>A report of an accident to the Police or an insurance company</a:t>
             </a:r>
-            <a:endParaRPr lang="en-US" sz="1650" dirty="0"/>
+            <a:endParaRPr lang="en-US" sz="1850" dirty="0"/>
           </a:p>
           <a:p>
             <a:pPr marL="228600" indent="-228600">
@@ -5336,7 +5336,7 @@
               <a:buChar char="•"/>
             </a:pPr>
             <a:r>
-              <a:rPr lang="en-US" sz="1650" dirty="0">
+              <a:rPr lang="en-US" sz="1850" dirty="0">
                 <a:solidFill>
                   <a:srgbClr val="002050"/>
                 </a:solidFill>
@@ -5346,7 +5346,7 @@
               </a:rPr>
               <a:t>A report of a social function, such as a wedding</a:t>
             </a:r>
-            <a:endParaRPr lang="en-US" sz="1650" dirty="0"/>
+            <a:endParaRPr lang="en-US" sz="1850" dirty="0"/>
           </a:p>
           <a:p>
             <a:pPr marL="228600" indent="-228600">
@@ -5360,7 +5360,7 @@
               <a:buChar char="•"/>
             </a:pPr>
             <a:r>
-              <a:rPr lang="en-US" sz="1650" dirty="0">
+              <a:rPr lang="en-US" sz="1850" dirty="0">
                 <a:solidFill>
                   <a:srgbClr val="002050"/>
                 </a:solidFill>
@@ -5370,7 +5370,7 @@
               </a:rPr>
               <a:t>A news report about an accident, meeting or noteworthy incident</a:t>
             </a:r>
-            <a:endParaRPr lang="en-US" sz="1650" dirty="0"/>
+            <a:endParaRPr lang="en-US" sz="1850" dirty="0"/>
           </a:p>
           <a:p>
             <a:pPr marL="228600" indent="-228600">
@@ -5384,7 +5384,7 @@
               <a:buChar char="•"/>
             </a:pPr>
             <a:r>
-              <a:rPr lang="en-US" sz="1650" dirty="0">
+              <a:rPr lang="en-US" sz="1850" dirty="0">
                 <a:solidFill>
                   <a:srgbClr val="002050"/>
                 </a:solidFill>
@@ -5394,7 +5394,7 @@
               </a:rPr>
               <a:t>A report of a commission of enquiry</a:t>
             </a:r>
-            <a:endParaRPr lang="en-US" sz="1650" dirty="0"/>
+            <a:endParaRPr lang="en-US" sz="1850" dirty="0"/>
           </a:p>
           <a:p>
             <a:pPr marL="228600" indent="-228600">
@@ -5408,7 +5408,7 @@
               <a:buChar char="•"/>
             </a:pPr>
             <a:r>
-              <a:rPr lang="en-US" sz="1650" dirty="0">
+              <a:rPr lang="en-US" sz="1850" dirty="0">
                 <a:solidFill>
                   <a:srgbClr val="002050"/>
                 </a:solidFill>
@@ -5418,7 +5418,7 @@
               </a:rPr>
               <a:t>A trade report</a:t>
             </a:r>
-            <a:endParaRPr lang="en-US" sz="1650" dirty="0"/>
+            <a:endParaRPr lang="en-US" sz="1850" dirty="0"/>
           </a:p>
           <a:p>
             <a:pPr marL="228600" indent="-228600">
@@ -5432,7 +5432,7 @@
               <a:buChar char="•"/>
             </a:pPr>
             <a:r>
-              <a:rPr lang="en-US" sz="1650" dirty="0">
+              <a:rPr lang="en-US" sz="1850" dirty="0">
                 <a:solidFill>
                   <a:srgbClr val="002050"/>
                 </a:solidFill>
@@ -5442,7 +5442,7 @@
               </a:rPr>
               <a:t>A company report or a Company Accident Report</a:t>
             </a:r>
-            <a:endParaRPr lang="en-US" sz="1650" dirty="0"/>
+            <a:endParaRPr lang="en-US" sz="1850" dirty="0"/>
           </a:p>
           <a:p>
             <a:pPr marL="228600" indent="-228600">
@@ -5456,7 +5456,7 @@
               <a:buChar char="•"/>
             </a:pPr>
             <a:r>
-              <a:rPr lang="en-US" sz="1650" dirty="0">
+              <a:rPr lang="en-US" sz="1850" dirty="0">
                 <a:solidFill>
                   <a:srgbClr val="002050"/>
                 </a:solidFill>
@@ -5466,7 +5466,7 @@
               </a:rPr>
               <a:t>An Annual Report by a Chairman or a Treasurer</a:t>
             </a:r>
-            <a:endParaRPr lang="en-US" sz="1650" dirty="0"/>
+            <a:endParaRPr lang="en-US" sz="1850" dirty="0"/>
           </a:p>
           <a:p>
             <a:pPr marL="228600" indent="-228600">
@@ -5480,7 +5480,7 @@
               <a:buChar char="•"/>
             </a:pPr>
             <a:r>
-              <a:rPr lang="en-US" sz="1650" dirty="0">
+              <a:rPr lang="en-US" sz="1850" dirty="0">
                 <a:solidFill>
                   <a:srgbClr val="002050"/>
                 </a:solidFill>
@@ -5490,7 +5490,7 @@
               </a:rPr>
               <a:t>An internal report on a business related matter following an investigation or collection of data</a:t>
             </a:r>
-            <a:endParaRPr lang="en-US" sz="1650" dirty="0"/>
+            <a:endParaRPr lang="en-US" sz="1850" dirty="0"/>
           </a:p>
         </p:txBody>
       </p:sp>
@@ -5632,8 +5632,8 @@
         </p:nvSpPr>
         <p:spPr>
           <a:xfrm>
-            <a:off x="502920" y="274320"/>
-            <a:ext cx="11183112" cy="329184"/>
+            <a:off x="502920" y="256032"/>
+            <a:ext cx="11183112" cy="347472"/>
           </a:xfrm>
           <a:prstGeom prst="rect">
             <a:avLst/>
@@ -5649,7 +5649,7 @@
               <a:buNone/>
             </a:pPr>
             <a:r>
-              <a:rPr lang="en-US" sz="1300" b="1" spc="200" kern="0" dirty="0">
+              <a:rPr lang="en-US" sz="1400" b="1" spc="200" kern="0" dirty="0">
                 <a:solidFill>
                   <a:srgbClr val="0F6CBD"/>
                 </a:solidFill>
@@ -5659,7 +5659,7 @@
               </a:rPr>
               <a:t>WORKED EXAMPLES</a:t>
             </a:r>
-            <a:endParaRPr lang="en-US" sz="1300" dirty="0"/>
+            <a:endParaRPr lang="en-US" sz="1400" dirty="0"/>
           </a:p>
         </p:txBody>
       </p:sp>
@@ -5671,8 +5671,8 @@
         </p:nvSpPr>
         <p:spPr>
           <a:xfrm>
-            <a:off x="502920" y="603504"/>
-            <a:ext cx="11183112" cy="749808"/>
+            <a:off x="502920" y="585216"/>
+            <a:ext cx="11183112" cy="786384"/>
           </a:xfrm>
           <a:prstGeom prst="rect">
             <a:avLst/>
@@ -5688,7 +5688,7 @@
               <a:buNone/>
             </a:pPr>
             <a:r>
-              <a:rPr lang="en-US" sz="3100" b="1" dirty="0">
+              <a:rPr lang="en-US" sz="3400" b="1" dirty="0">
                 <a:solidFill>
                   <a:srgbClr val="002050"/>
                 </a:solidFill>
@@ -5698,7 +5698,7 @@
               </a:rPr>
               <a:t>Investec Sample Reports — 7 Worked Models</a:t>
             </a:r>
-            <a:endParaRPr lang="en-US" sz="3100" dirty="0"/>
+            <a:endParaRPr lang="en-US" sz="3400" dirty="0"/>
           </a:p>
         </p:txBody>
       </p:sp>
@@ -5727,7 +5727,7 @@
               <a:buNone/>
             </a:pPr>
             <a:r>
-              <a:rPr lang="en-US" sz="1450" dirty="0">
+              <a:rPr lang="en-US" sz="1600" dirty="0">
                 <a:solidFill>
                   <a:srgbClr val="6B7280"/>
                 </a:solidFill>
@@ -5737,7 +5737,7 @@
               </a:rPr>
               <a:t>Use these models to practise matching report type, purpose, audience and recommended action.</a:t>
             </a:r>
-            <a:endParaRPr lang="en-US" sz="1450" dirty="0"/>
+            <a:endParaRPr lang="en-US" sz="1600" dirty="0"/>
           </a:p>
         </p:txBody>
       </p:sp>
@@ -5768,7 +5768,7 @@
                 <a:gridCol w="2286000"/>
                 <a:gridCol w="8119872"/>
               </a:tblGrid>
-              <a:tr h="512064">
+              <a:tr h="566928">
                 <a:tc>
                   <a:txBody>
                     <a:bodyPr/>
@@ -5778,7 +5778,7 @@
                         <a:buNone/>
                       </a:pPr>
                       <a:r>
-                        <a:rPr lang="en-US" sz="1350" b="1" dirty="0">
+                        <a:rPr lang="en-US" sz="1500" b="1" dirty="0">
                           <a:solidFill>
                             <a:srgbClr val="FFFFFF"/>
                           </a:solidFill>
@@ -5788,7 +5788,7 @@
                         </a:rPr>
                         <a:t>No.</a:t>
                       </a:r>
-                      <a:endParaRPr lang="en-US" sz="1350" dirty="0">
+                      <a:endParaRPr lang="en-US" sz="1500" dirty="0">
                         <a:latin typeface="Aptos Display" charset="0"/>
                         <a:ea typeface="Aptos Display" charset="0"/>
                         <a:cs typeface="Aptos Display" charset="0"/>
@@ -5846,7 +5846,7 @@
                         <a:buNone/>
                       </a:pPr>
                       <a:r>
-                        <a:rPr lang="en-US" sz="1350" b="1" dirty="0">
+                        <a:rPr lang="en-US" sz="1500" b="1" dirty="0">
                           <a:solidFill>
                             <a:srgbClr val="FFFFFF"/>
                           </a:solidFill>
@@ -5856,7 +5856,7 @@
                         </a:rPr>
                         <a:t>Report type</a:t>
                       </a:r>
-                      <a:endParaRPr lang="en-US" sz="1350" dirty="0">
+                      <a:endParaRPr lang="en-US" sz="1500" dirty="0">
                         <a:latin typeface="Aptos Display" charset="0"/>
                         <a:ea typeface="Aptos Display" charset="0"/>
                         <a:cs typeface="Aptos Display" charset="0"/>
@@ -5914,7 +5914,7 @@
                         <a:buNone/>
                       </a:pPr>
                       <a:r>
-                        <a:rPr lang="en-US" sz="1350" b="1" dirty="0">
+                        <a:rPr lang="en-US" sz="1500" b="1" dirty="0">
                           <a:solidFill>
                             <a:srgbClr val="FFFFFF"/>
                           </a:solidFill>
@@ -5924,7 +5924,7 @@
                         </a:rPr>
                         <a:t>Investec systems support example</a:t>
                       </a:r>
-                      <a:endParaRPr lang="en-US" sz="1350" dirty="0">
+                      <a:endParaRPr lang="en-US" sz="1500" dirty="0">
                         <a:latin typeface="Aptos Display" charset="0"/>
                         <a:ea typeface="Aptos Display" charset="0"/>
                         <a:cs typeface="Aptos Display" charset="0"/>
@@ -5974,7 +5974,7 @@
                   </a:tcPr>
                 </a:tc>
               </a:tr>
-              <a:tr h="512064">
+              <a:tr h="566928">
                 <a:tc>
                   <a:txBody>
                     <a:bodyPr/>
@@ -5984,7 +5984,7 @@
                         <a:buNone/>
                       </a:pPr>
                       <a:r>
-                        <a:rPr lang="en-US" sz="1350" dirty="0">
+                        <a:rPr lang="en-US" sz="1500" dirty="0">
                           <a:solidFill>
                             <a:srgbClr val="002050"/>
                           </a:solidFill>
@@ -5994,7 +5994,7 @@
                         </a:rPr>
                         <a:t>1</a:t>
                       </a:r>
-                      <a:endParaRPr lang="en-US" sz="1350" dirty="0">
+                      <a:endParaRPr lang="en-US" sz="1500" dirty="0">
                         <a:latin typeface="Aptos" charset="0"/>
                         <a:ea typeface="Aptos" charset="0"/>
                         <a:cs typeface="Aptos" charset="0"/>
@@ -6052,7 +6052,7 @@
                         <a:buNone/>
                       </a:pPr>
                       <a:r>
-                        <a:rPr lang="en-US" sz="1350" dirty="0">
+                        <a:rPr lang="en-US" sz="1500" dirty="0">
                           <a:solidFill>
                             <a:srgbClr val="002050"/>
                           </a:solidFill>
@@ -6062,7 +6062,7 @@
                         </a:rPr>
                         <a:t>Incident</a:t>
                       </a:r>
-                      <a:endParaRPr lang="en-US" sz="1350" dirty="0">
+                      <a:endParaRPr lang="en-US" sz="1500" dirty="0">
                         <a:latin typeface="Aptos" charset="0"/>
                         <a:ea typeface="Aptos" charset="0"/>
                         <a:cs typeface="Aptos" charset="0"/>
@@ -6120,7 +6120,7 @@
                         <a:buNone/>
                       </a:pPr>
                       <a:r>
-                        <a:rPr lang="en-US" sz="1350" dirty="0">
+                        <a:rPr lang="en-US" sz="1500" dirty="0">
                           <a:solidFill>
                             <a:srgbClr val="002050"/>
                           </a:solidFill>
@@ -6130,7 +6130,7 @@
                         </a:rPr>
                         <a:t>Online Banking login outage — immediate facts, impact, action taken and escalation</a:t>
                       </a:r>
-                      <a:endParaRPr lang="en-US" sz="1350" dirty="0">
+                      <a:endParaRPr lang="en-US" sz="1500" dirty="0">
                         <a:latin typeface="Aptos" charset="0"/>
                         <a:ea typeface="Aptos" charset="0"/>
                         <a:cs typeface="Aptos" charset="0"/>
@@ -6180,7 +6180,7 @@
                   </a:tcPr>
                 </a:tc>
               </a:tr>
-              <a:tr h="512064">
+              <a:tr h="566928">
                 <a:tc>
                   <a:txBody>
                     <a:bodyPr/>
@@ -6190,7 +6190,7 @@
                         <a:buNone/>
                       </a:pPr>
                       <a:r>
-                        <a:rPr lang="en-US" sz="1350" dirty="0">
+                        <a:rPr lang="en-US" sz="1500" dirty="0">
                           <a:solidFill>
                             <a:srgbClr val="002050"/>
                           </a:solidFill>
@@ -6200,7 +6200,7 @@
                         </a:rPr>
                         <a:t>2</a:t>
                       </a:r>
-                      <a:endParaRPr lang="en-US" sz="1350" dirty="0">
+                      <a:endParaRPr lang="en-US" sz="1500" dirty="0">
                         <a:latin typeface="Aptos" charset="0"/>
                         <a:ea typeface="Aptos" charset="0"/>
                         <a:cs typeface="Aptos" charset="0"/>
@@ -6258,7 +6258,7 @@
                         <a:buNone/>
                       </a:pPr>
                       <a:r>
-                        <a:rPr lang="en-US" sz="1350" dirty="0">
+                        <a:rPr lang="en-US" sz="1500" dirty="0">
                           <a:solidFill>
                             <a:srgbClr val="002050"/>
                           </a:solidFill>
@@ -6268,7 +6268,7 @@
                         </a:rPr>
                         <a:t>Incident</a:t>
                       </a:r>
-                      <a:endParaRPr lang="en-US" sz="1350" dirty="0">
+                      <a:endParaRPr lang="en-US" sz="1500" dirty="0">
                         <a:latin typeface="Aptos" charset="0"/>
                         <a:ea typeface="Aptos" charset="0"/>
                         <a:cs typeface="Aptos" charset="0"/>
@@ -6326,7 +6326,7 @@
                         <a:buNone/>
                       </a:pPr>
                       <a:r>
-                        <a:rPr lang="en-US" sz="1350" dirty="0">
+                        <a:rPr lang="en-US" sz="1500" dirty="0">
                           <a:solidFill>
                             <a:srgbClr val="002050"/>
                           </a:solidFill>
@@ -6336,7 +6336,7 @@
                         </a:rPr>
                         <a:t>Lost corporate laptop — data risk, containment and compliance notification</a:t>
                       </a:r>
-                      <a:endParaRPr lang="en-US" sz="1350" dirty="0">
+                      <a:endParaRPr lang="en-US" sz="1500" dirty="0">
                         <a:latin typeface="Aptos" charset="0"/>
                         <a:ea typeface="Aptos" charset="0"/>
                         <a:cs typeface="Aptos" charset="0"/>
@@ -6386,7 +6386,7 @@
                   </a:tcPr>
                 </a:tc>
               </a:tr>
-              <a:tr h="512064">
+              <a:tr h="566928">
                 <a:tc>
                   <a:txBody>
                     <a:bodyPr/>
@@ -6396,7 +6396,7 @@
                         <a:buNone/>
                       </a:pPr>
                       <a:r>
-                        <a:rPr lang="en-US" sz="1350" dirty="0">
+                        <a:rPr lang="en-US" sz="1500" dirty="0">
                           <a:solidFill>
                             <a:srgbClr val="002050"/>
                           </a:solidFill>
@@ -6406,7 +6406,7 @@
                         </a:rPr>
                         <a:t>3</a:t>
                       </a:r>
-                      <a:endParaRPr lang="en-US" sz="1350" dirty="0">
+                      <a:endParaRPr lang="en-US" sz="1500" dirty="0">
                         <a:latin typeface="Aptos" charset="0"/>
                         <a:ea typeface="Aptos" charset="0"/>
                         <a:cs typeface="Aptos" charset="0"/>
@@ -6464,7 +6464,7 @@
                         <a:buNone/>
                       </a:pPr>
                       <a:r>
-                        <a:rPr lang="en-US" sz="1350" dirty="0">
+                        <a:rPr lang="en-US" sz="1500" dirty="0">
                           <a:solidFill>
                             <a:srgbClr val="002050"/>
                           </a:solidFill>
@@ -6474,7 +6474,7 @@
                         </a:rPr>
                         <a:t>Investigation</a:t>
                       </a:r>
-                      <a:endParaRPr lang="en-US" sz="1350" dirty="0">
+                      <a:endParaRPr lang="en-US" sz="1500" dirty="0">
                         <a:latin typeface="Aptos" charset="0"/>
                         <a:ea typeface="Aptos" charset="0"/>
                         <a:cs typeface="Aptos" charset="0"/>
@@ -6532,7 +6532,7 @@
                         <a:buNone/>
                       </a:pPr>
                       <a:r>
-                        <a:rPr lang="en-US" sz="1350" dirty="0">
+                        <a:rPr lang="en-US" sz="1500" dirty="0">
                           <a:solidFill>
                             <a:srgbClr val="002050"/>
                           </a:solidFill>
@@ -6542,7 +6542,7 @@
                         </a:rPr>
                         <a:t>Repeated VPN disconnections — evidence, root cause and conclusion</a:t>
                       </a:r>
-                      <a:endParaRPr lang="en-US" sz="1350" dirty="0">
+                      <a:endParaRPr lang="en-US" sz="1500" dirty="0">
                         <a:latin typeface="Aptos" charset="0"/>
                         <a:ea typeface="Aptos" charset="0"/>
                         <a:cs typeface="Aptos" charset="0"/>
@@ -6592,7 +6592,7 @@
                   </a:tcPr>
                 </a:tc>
               </a:tr>
-              <a:tr h="512064">
+              <a:tr h="566928">
                 <a:tc>
                   <a:txBody>
                     <a:bodyPr/>
@@ -6602,7 +6602,7 @@
                         <a:buNone/>
                       </a:pPr>
                       <a:r>
-                        <a:rPr lang="en-US" sz="1350" dirty="0">
+                        <a:rPr lang="en-US" sz="1500" dirty="0">
                           <a:solidFill>
                             <a:srgbClr val="002050"/>
                           </a:solidFill>
@@ -6612,7 +6612,7 @@
                         </a:rPr>
                         <a:t>4</a:t>
                       </a:r>
-                      <a:endParaRPr lang="en-US" sz="1350" dirty="0">
+                      <a:endParaRPr lang="en-US" sz="1500" dirty="0">
                         <a:latin typeface="Aptos" charset="0"/>
                         <a:ea typeface="Aptos" charset="0"/>
                         <a:cs typeface="Aptos" charset="0"/>
@@ -6670,7 +6670,7 @@
                         <a:buNone/>
                       </a:pPr>
                       <a:r>
-                        <a:rPr lang="en-US" sz="1350" dirty="0">
+                        <a:rPr lang="en-US" sz="1500" dirty="0">
                           <a:solidFill>
                             <a:srgbClr val="002050"/>
                           </a:solidFill>
@@ -6680,7 +6680,7 @@
                         </a:rPr>
                         <a:t>Investigation</a:t>
                       </a:r>
-                      <a:endParaRPr lang="en-US" sz="1350" dirty="0">
+                      <a:endParaRPr lang="en-US" sz="1500" dirty="0">
                         <a:latin typeface="Aptos" charset="0"/>
                         <a:ea typeface="Aptos" charset="0"/>
                         <a:cs typeface="Aptos" charset="0"/>
@@ -6738,7 +6738,7 @@
                         <a:buNone/>
                       </a:pPr>
                       <a:r>
-                        <a:rPr lang="en-US" sz="1350" dirty="0">
+                        <a:rPr lang="en-US" sz="1500" dirty="0">
                           <a:solidFill>
                             <a:srgbClr val="002050"/>
                           </a:solidFill>
@@ -6748,7 +6748,7 @@
                         </a:rPr>
                         <a:t>Print-cost increase — data analysis, findings and controls</a:t>
                       </a:r>
-                      <a:endParaRPr lang="en-US" sz="1350" dirty="0">
+                      <a:endParaRPr lang="en-US" sz="1500" dirty="0">
                         <a:latin typeface="Aptos" charset="0"/>
                         <a:ea typeface="Aptos" charset="0"/>
                         <a:cs typeface="Aptos" charset="0"/>
@@ -6798,7 +6798,7 @@
                   </a:tcPr>
                 </a:tc>
               </a:tr>
-              <a:tr h="512064">
+              <a:tr h="566928">
                 <a:tc>
                   <a:txBody>
                     <a:bodyPr/>
@@ -6808,7 +6808,7 @@
                         <a:buNone/>
                       </a:pPr>
                       <a:r>
-                        <a:rPr lang="en-US" sz="1350" dirty="0">
+                        <a:rPr lang="en-US" sz="1500" dirty="0">
                           <a:solidFill>
                             <a:srgbClr val="002050"/>
                           </a:solidFill>
@@ -6818,7 +6818,7 @@
                         </a:rPr>
                         <a:t>5</a:t>
                       </a:r>
-                      <a:endParaRPr lang="en-US" sz="1350" dirty="0">
+                      <a:endParaRPr lang="en-US" sz="1500" dirty="0">
                         <a:latin typeface="Aptos" charset="0"/>
                         <a:ea typeface="Aptos" charset="0"/>
                         <a:cs typeface="Aptos" charset="0"/>
@@ -6876,7 +6876,7 @@
                         <a:buNone/>
                       </a:pPr>
                       <a:r>
-                        <a:rPr lang="en-US" sz="1350" dirty="0">
+                        <a:rPr lang="en-US" sz="1500" dirty="0">
                           <a:solidFill>
                             <a:srgbClr val="002050"/>
                           </a:solidFill>
@@ -6886,7 +6886,7 @@
                         </a:rPr>
                         <a:t>Project status</a:t>
                       </a:r>
-                      <a:endParaRPr lang="en-US" sz="1350" dirty="0">
+                      <a:endParaRPr lang="en-US" sz="1500" dirty="0">
                         <a:latin typeface="Aptos" charset="0"/>
                         <a:ea typeface="Aptos" charset="0"/>
                         <a:cs typeface="Aptos" charset="0"/>
@@ -6944,7 +6944,7 @@
                         <a:buNone/>
                       </a:pPr>
                       <a:r>
-                        <a:rPr lang="en-US" sz="1350" dirty="0">
+                        <a:rPr lang="en-US" sz="1500" dirty="0">
                           <a:solidFill>
                             <a:srgbClr val="002050"/>
                           </a:solidFill>
@@ -6954,7 +6954,7 @@
                         </a:rPr>
                         <a:t>Windows 11 pilot rollout — progress, risks, issues and next steps</a:t>
                       </a:r>
-                      <a:endParaRPr lang="en-US" sz="1350" dirty="0">
+                      <a:endParaRPr lang="en-US" sz="1500" dirty="0">
                         <a:latin typeface="Aptos" charset="0"/>
                         <a:ea typeface="Aptos" charset="0"/>
                         <a:cs typeface="Aptos" charset="0"/>
@@ -7004,7 +7004,7 @@
                   </a:tcPr>
                 </a:tc>
               </a:tr>
-              <a:tr h="512064">
+              <a:tr h="566928">
                 <a:tc>
                   <a:txBody>
                     <a:bodyPr/>
@@ -7014,7 +7014,7 @@
                         <a:buNone/>
                       </a:pPr>
                       <a:r>
-                        <a:rPr lang="en-US" sz="1350" dirty="0">
+                        <a:rPr lang="en-US" sz="1500" dirty="0">
                           <a:solidFill>
                             <a:srgbClr val="002050"/>
                           </a:solidFill>
@@ -7024,7 +7024,7 @@
                         </a:rPr>
                         <a:t>6</a:t>
                       </a:r>
-                      <a:endParaRPr lang="en-US" sz="1350" dirty="0">
+                      <a:endParaRPr lang="en-US" sz="1500" dirty="0">
                         <a:latin typeface="Aptos" charset="0"/>
                         <a:ea typeface="Aptos" charset="0"/>
                         <a:cs typeface="Aptos" charset="0"/>
@@ -7082,7 +7082,7 @@
                         <a:buNone/>
                       </a:pPr>
                       <a:r>
-                        <a:rPr lang="en-US" sz="1350" dirty="0">
+                        <a:rPr lang="en-US" sz="1500" dirty="0">
                           <a:solidFill>
                             <a:srgbClr val="002050"/>
                           </a:solidFill>
@@ -7092,7 +7092,7 @@
                         </a:rPr>
                         <a:t>Project status</a:t>
                       </a:r>
-                      <a:endParaRPr lang="en-US" sz="1350" dirty="0">
+                      <a:endParaRPr lang="en-US" sz="1500" dirty="0">
                         <a:latin typeface="Aptos" charset="0"/>
                         <a:ea typeface="Aptos" charset="0"/>
                         <a:cs typeface="Aptos" charset="0"/>
@@ -7150,7 +7150,7 @@
                         <a:buNone/>
                       </a:pPr>
                       <a:r>
-                        <a:rPr lang="en-US" sz="1350" dirty="0">
+                        <a:rPr lang="en-US" sz="1500" dirty="0">
                           <a:solidFill>
                             <a:srgbClr val="002050"/>
                           </a:solidFill>
@@ -7160,7 +7160,7 @@
                         </a:rPr>
                         <a:t>Branch Wi-Fi upgrade — milestone status and blockers</a:t>
                       </a:r>
-                      <a:endParaRPr lang="en-US" sz="1350" dirty="0">
+                      <a:endParaRPr lang="en-US" sz="1500" dirty="0">
                         <a:latin typeface="Aptos" charset="0"/>
                         <a:ea typeface="Aptos" charset="0"/>
                         <a:cs typeface="Aptos" charset="0"/>
@@ -7210,7 +7210,7 @@
                   </a:tcPr>
                 </a:tc>
               </a:tr>
-              <a:tr h="512064">
+              <a:tr h="566928">
                 <a:tc>
                   <a:txBody>
                     <a:bodyPr/>
@@ -7220,7 +7220,7 @@
                         <a:buNone/>
                       </a:pPr>
                       <a:r>
-                        <a:rPr lang="en-US" sz="1350" dirty="0">
+                        <a:rPr lang="en-US" sz="1500" dirty="0">
                           <a:solidFill>
                             <a:srgbClr val="002050"/>
                           </a:solidFill>
@@ -7230,7 +7230,7 @@
                         </a:rPr>
                         <a:t>7</a:t>
                       </a:r>
-                      <a:endParaRPr lang="en-US" sz="1350" dirty="0">
+                      <a:endParaRPr lang="en-US" sz="1500" dirty="0">
                         <a:latin typeface="Aptos" charset="0"/>
                         <a:ea typeface="Aptos" charset="0"/>
                         <a:cs typeface="Aptos" charset="0"/>
@@ -7288,7 +7288,7 @@
                         <a:buNone/>
                       </a:pPr>
                       <a:r>
-                        <a:rPr lang="en-US" sz="1350" dirty="0">
+                        <a:rPr lang="en-US" sz="1500" dirty="0">
                           <a:solidFill>
                             <a:srgbClr val="002050"/>
                           </a:solidFill>
@@ -7298,7 +7298,7 @@
                         </a:rPr>
                         <a:t>Recommendation</a:t>
                       </a:r>
-                      <a:endParaRPr lang="en-US" sz="1350" dirty="0">
+                      <a:endParaRPr lang="en-US" sz="1500" dirty="0">
                         <a:latin typeface="Aptos" charset="0"/>
                         <a:ea typeface="Aptos" charset="0"/>
                         <a:cs typeface="Aptos" charset="0"/>
@@ -7356,7 +7356,7 @@
                         <a:buNone/>
                       </a:pPr>
                       <a:r>
-                        <a:rPr lang="en-US" sz="1350" dirty="0">
+                        <a:rPr lang="en-US" sz="1500" dirty="0">
                           <a:solidFill>
                             <a:srgbClr val="002050"/>
                           </a:solidFill>
@@ -7366,7 +7366,7 @@
                         </a:rPr>
                         <a:t>Service desk knowledge base — proposed solution, cost and decision needed</a:t>
                       </a:r>
-                      <a:endParaRPr lang="en-US" sz="1350" dirty="0">
+                      <a:endParaRPr lang="en-US" sz="1500" dirty="0">
                         <a:latin typeface="Aptos" charset="0"/>
                         <a:ea typeface="Aptos" charset="0"/>
                         <a:cs typeface="Aptos" charset="0"/>
@@ -7558,8 +7558,8 @@
         </p:nvSpPr>
         <p:spPr>
           <a:xfrm>
-            <a:off x="502920" y="274320"/>
-            <a:ext cx="11183112" cy="329184"/>
+            <a:off x="502920" y="256032"/>
+            <a:ext cx="11183112" cy="347472"/>
           </a:xfrm>
           <a:prstGeom prst="rect">
             <a:avLst/>
@@ -7575,7 +7575,7 @@
               <a:buNone/>
             </a:pPr>
             <a:r>
-              <a:rPr lang="en-US" sz="1300" b="1" spc="200" kern="0" dirty="0">
+              <a:rPr lang="en-US" sz="1400" b="1" spc="200" kern="0" dirty="0">
                 <a:solidFill>
                   <a:srgbClr val="0F6CBD"/>
                 </a:solidFill>
@@ -7585,7 +7585,7 @@
               </a:rPr>
               <a:t>WORKED EXAMPLES · INCIDENT</a:t>
             </a:r>
-            <a:endParaRPr lang="en-US" sz="1300" dirty="0"/>
+            <a:endParaRPr lang="en-US" sz="1400" dirty="0"/>
           </a:p>
         </p:txBody>
       </p:sp>
@@ -7597,8 +7597,8 @@
         </p:nvSpPr>
         <p:spPr>
           <a:xfrm>
-            <a:off x="502920" y="603504"/>
-            <a:ext cx="11183112" cy="749808"/>
+            <a:off x="502920" y="585216"/>
+            <a:ext cx="11183112" cy="786384"/>
           </a:xfrm>
           <a:prstGeom prst="rect">
             <a:avLst/>
@@ -7614,7 +7614,7 @@
               <a:buNone/>
             </a:pPr>
             <a:r>
-              <a:rPr lang="en-US" sz="3100" b="1" dirty="0">
+              <a:rPr lang="en-US" sz="3400" b="1" dirty="0">
                 <a:solidFill>
                   <a:srgbClr val="002050"/>
                 </a:solidFill>
@@ -7624,7 +7624,7 @@
               </a:rPr>
               <a:t>Sample Incident Reports</a:t>
             </a:r>
-            <a:endParaRPr lang="en-US" sz="3100" dirty="0"/>
+            <a:endParaRPr lang="en-US" sz="3400" dirty="0"/>
           </a:p>
         </p:txBody>
       </p:sp>
@@ -7653,7 +7653,7 @@
               <a:buNone/>
             </a:pPr>
             <a:r>
-              <a:rPr lang="en-US" sz="1500" dirty="0">
+              <a:rPr lang="en-US" sz="1650" dirty="0">
                 <a:solidFill>
                   <a:srgbClr val="6B7280"/>
                 </a:solidFill>
@@ -7663,7 +7663,7 @@
               </a:rPr>
               <a:t>Incident reports answer: What happened, who was affected, what immediate action was taken and what must happen next?</a:t>
             </a:r>
-            <a:endParaRPr lang="en-US" sz="1500" dirty="0"/>
+            <a:endParaRPr lang="en-US" sz="1650" dirty="0"/>
           </a:p>
         </p:txBody>
       </p:sp>
@@ -7749,7 +7749,7 @@
               <a:buNone/>
             </a:pPr>
             <a:r>
-              <a:rPr lang="en-US" sz="1700" b="1" dirty="0">
+              <a:rPr lang="en-US" sz="1900" b="1" dirty="0">
                 <a:solidFill>
                   <a:srgbClr val="002050"/>
                 </a:solidFill>
@@ -7767,7 +7767,7 @@
               <a:buNone/>
             </a:pPr>
             <a:r>
-              <a:rPr lang="en-US" sz="1400" dirty="0">
+              <a:rPr lang="en-US" sz="1550" dirty="0">
                 <a:solidFill>
                   <a:srgbClr val="002050"/>
                 </a:solidFill>
@@ -7777,7 +7777,7 @@
               </a:rPr>
               <a:t>At 09:12 on 6 August 2026, monitoring reported elevated login failures. About 18% of attempted logins failed until 09:47 and the Service Desk logged 43 related calls. Action: escalate to Digital Channels Support, publish an internal advisory and monitor recovery after the authentication node restart.</a:t>
             </a:r>
-            <a:endParaRPr lang="en-US" sz="1700" dirty="0"/>
+            <a:endParaRPr lang="en-US" sz="1900" dirty="0"/>
           </a:p>
         </p:txBody>
       </p:sp>
@@ -7863,7 +7863,7 @@
               <a:buNone/>
             </a:pPr>
             <a:r>
-              <a:rPr lang="en-US" sz="1700" b="1" dirty="0">
+              <a:rPr lang="en-US" sz="1900" b="1" dirty="0">
                 <a:solidFill>
                   <a:srgbClr val="002050"/>
                 </a:solidFill>
@@ -7881,7 +7881,7 @@
               <a:buNone/>
             </a:pPr>
             <a:r>
-              <a:rPr lang="en-US" sz="1400" dirty="0">
+              <a:rPr lang="en-US" sz="1550" dirty="0">
                 <a:solidFill>
                   <a:srgbClr val="002050"/>
                 </a:solidFill>
@@ -7891,7 +7891,7 @@
               </a:rPr>
               <a:t>A Relationship Manager reported a lost encrypted laptop at 17:40 on 12 August 2026. IT Security initiated remote lock and wipe, disabled cached sessions and opened a compliance notification ticket. Follow-up: manager sign-off, replacement device and travel security refresher.</a:t>
             </a:r>
-            <a:endParaRPr lang="en-US" sz="1700" dirty="0"/>
+            <a:endParaRPr lang="en-US" sz="1900" dirty="0"/>
           </a:p>
         </p:txBody>
       </p:sp>
@@ -8033,8 +8033,8 @@
         </p:nvSpPr>
         <p:spPr>
           <a:xfrm>
-            <a:off x="502920" y="274320"/>
-            <a:ext cx="11183112" cy="329184"/>
+            <a:off x="502920" y="256032"/>
+            <a:ext cx="11183112" cy="347472"/>
           </a:xfrm>
           <a:prstGeom prst="rect">
             <a:avLst/>
@@ -8050,7 +8050,7 @@
               <a:buNone/>
             </a:pPr>
             <a:r>
-              <a:rPr lang="en-US" sz="1300" b="1" spc="200" kern="0" dirty="0">
+              <a:rPr lang="en-US" sz="1400" b="1" spc="200" kern="0" dirty="0">
                 <a:solidFill>
                   <a:srgbClr val="0F6CBD"/>
                 </a:solidFill>
@@ -8060,7 +8060,7 @@
               </a:rPr>
               <a:t>WORKED EXAMPLES · INVESTIGATION</a:t>
             </a:r>
-            <a:endParaRPr lang="en-US" sz="1300" dirty="0"/>
+            <a:endParaRPr lang="en-US" sz="1400" dirty="0"/>
           </a:p>
         </p:txBody>
       </p:sp>
@@ -8072,8 +8072,8 @@
         </p:nvSpPr>
         <p:spPr>
           <a:xfrm>
-            <a:off x="502920" y="603504"/>
-            <a:ext cx="11183112" cy="749808"/>
+            <a:off x="502920" y="585216"/>
+            <a:ext cx="11183112" cy="786384"/>
           </a:xfrm>
           <a:prstGeom prst="rect">
             <a:avLst/>
@@ -8089,7 +8089,7 @@
               <a:buNone/>
             </a:pPr>
             <a:r>
-              <a:rPr lang="en-US" sz="3100" b="1" dirty="0">
+              <a:rPr lang="en-US" sz="3400" b="1" dirty="0">
                 <a:solidFill>
                   <a:srgbClr val="002050"/>
                 </a:solidFill>
@@ -8099,7 +8099,7 @@
               </a:rPr>
               <a:t>Sample Investigation Reports</a:t>
             </a:r>
-            <a:endParaRPr lang="en-US" sz="3100" dirty="0"/>
+            <a:endParaRPr lang="en-US" sz="3400" dirty="0"/>
           </a:p>
         </p:txBody>
       </p:sp>
@@ -8128,7 +8128,7 @@
               <a:buNone/>
             </a:pPr>
             <a:r>
-              <a:rPr lang="en-US" sz="1500" dirty="0">
+              <a:rPr lang="en-US" sz="1650" dirty="0">
                 <a:solidFill>
                   <a:srgbClr val="6B7280"/>
                 </a:solidFill>
@@ -8138,7 +8138,7 @@
               </a:rPr>
               <a:t>Investigation reports answer: What evidence was gathered, what caused the problem and what conclusion is supported by the facts?</a:t>
             </a:r>
-            <a:endParaRPr lang="en-US" sz="1500" dirty="0"/>
+            <a:endParaRPr lang="en-US" sz="1650" dirty="0"/>
           </a:p>
         </p:txBody>
       </p:sp>
@@ -8224,7 +8224,7 @@
               <a:buNone/>
             </a:pPr>
             <a:r>
-              <a:rPr lang="en-US" sz="1700" b="1" dirty="0">
+              <a:rPr lang="en-US" sz="1900" b="1" dirty="0">
                 <a:solidFill>
                   <a:srgbClr val="002050"/>
                 </a:solidFill>
@@ -8242,7 +8242,7 @@
               <a:buNone/>
             </a:pPr>
             <a:r>
-              <a:rPr lang="en-US" sz="1400" dirty="0">
+              <a:rPr lang="en-US" sz="1550" dirty="0">
                 <a:solidFill>
                   <a:srgbClr val="002050"/>
                 </a:solidFill>
@@ -8252,7 +8252,7 @@
               </a:rPr>
               <a:t>Review of 28 VPN tickets, firewall logs, endpoint versions and interviews showed that affected laptops were running an outdated VPN client after a staged update failed on one device group. Conclusion: the root cause was incomplete deployment validation.</a:t>
             </a:r>
-            <a:endParaRPr lang="en-US" sz="1700" dirty="0"/>
+            <a:endParaRPr lang="en-US" sz="1900" dirty="0"/>
           </a:p>
         </p:txBody>
       </p:sp>
@@ -8338,7 +8338,7 @@
               <a:buNone/>
             </a:pPr>
             <a:r>
-              <a:rPr lang="en-US" sz="1700" b="1" dirty="0">
+              <a:rPr lang="en-US" sz="1900" b="1" dirty="0">
                 <a:solidFill>
                   <a:srgbClr val="002050"/>
                 </a:solidFill>
@@ -8356,7 +8356,7 @@
               <a:buNone/>
             </a:pPr>
             <a:r>
-              <a:rPr lang="en-US" sz="1400" dirty="0">
+              <a:rPr lang="en-US" sz="1550" dirty="0">
                 <a:solidFill>
                   <a:srgbClr val="002050"/>
                 </a:solidFill>
@@ -8366,7 +8366,7 @@
               </a:rPr>
               <a:t>Print management data showed a 32% cost increase on Sandton 5th-floor devices. Findings showed default colour printing was enabled after a driver update and secure-release settings were missing on two devices. Conclusion: print policy controls were removed during the update.</a:t>
             </a:r>
-            <a:endParaRPr lang="en-US" sz="1700" dirty="0"/>
+            <a:endParaRPr lang="en-US" sz="1900" dirty="0"/>
           </a:p>
         </p:txBody>
       </p:sp>
@@ -8508,8 +8508,8 @@
         </p:nvSpPr>
         <p:spPr>
           <a:xfrm>
-            <a:off x="502920" y="274320"/>
-            <a:ext cx="11183112" cy="329184"/>
+            <a:off x="502920" y="256032"/>
+            <a:ext cx="11183112" cy="347472"/>
           </a:xfrm>
           <a:prstGeom prst="rect">
             <a:avLst/>
@@ -8525,7 +8525,7 @@
               <a:buNone/>
             </a:pPr>
             <a:r>
-              <a:rPr lang="en-US" sz="1300" b="1" spc="200" kern="0" dirty="0">
+              <a:rPr lang="en-US" sz="1400" b="1" spc="200" kern="0" dirty="0">
                 <a:solidFill>
                   <a:srgbClr val="0F6CBD"/>
                 </a:solidFill>
@@ -8535,7 +8535,7 @@
               </a:rPr>
               <a:t>WORKED EXAMPLES · PROJECT STATUS</a:t>
             </a:r>
-            <a:endParaRPr lang="en-US" sz="1300" dirty="0"/>
+            <a:endParaRPr lang="en-US" sz="1400" dirty="0"/>
           </a:p>
         </p:txBody>
       </p:sp>
@@ -8547,8 +8547,8 @@
         </p:nvSpPr>
         <p:spPr>
           <a:xfrm>
-            <a:off x="502920" y="603504"/>
-            <a:ext cx="11183112" cy="749808"/>
+            <a:off x="502920" y="585216"/>
+            <a:ext cx="11183112" cy="786384"/>
           </a:xfrm>
           <a:prstGeom prst="rect">
             <a:avLst/>
@@ -8564,7 +8564,7 @@
               <a:buNone/>
             </a:pPr>
             <a:r>
-              <a:rPr lang="en-US" sz="3100" b="1" dirty="0">
+              <a:rPr lang="en-US" sz="3400" b="1" dirty="0">
                 <a:solidFill>
                   <a:srgbClr val="002050"/>
                 </a:solidFill>
@@ -8574,7 +8574,7 @@
               </a:rPr>
               <a:t>Sample Project Status Reports</a:t>
             </a:r>
-            <a:endParaRPr lang="en-US" sz="3100" dirty="0"/>
+            <a:endParaRPr lang="en-US" sz="3400" dirty="0"/>
           </a:p>
         </p:txBody>
       </p:sp>
@@ -8603,7 +8603,7 @@
               <a:buNone/>
             </a:pPr>
             <a:r>
-              <a:rPr lang="en-US" sz="1500" dirty="0">
+              <a:rPr lang="en-US" sz="1650" dirty="0">
                 <a:solidFill>
                   <a:srgbClr val="6B7280"/>
                 </a:solidFill>
@@ -8613,7 +8613,7 @@
               </a:rPr>
               <a:t>Project status reports answer: Is the project on track against scope, time, cost, quality, risks and next milestones?</a:t>
             </a:r>
-            <a:endParaRPr lang="en-US" sz="1500" dirty="0"/>
+            <a:endParaRPr lang="en-US" sz="1650" dirty="0"/>
           </a:p>
         </p:txBody>
       </p:sp>
@@ -8699,7 +8699,7 @@
               <a:buNone/>
             </a:pPr>
             <a:r>
-              <a:rPr lang="en-US" sz="1700" b="1" dirty="0">
+              <a:rPr lang="en-US" sz="1900" b="1" dirty="0">
                 <a:solidFill>
                   <a:srgbClr val="002050"/>
                 </a:solidFill>
@@ -8717,7 +8717,7 @@
               <a:buNone/>
             </a:pPr>
             <a:r>
-              <a:rPr lang="en-US" sz="1400" dirty="0">
+              <a:rPr lang="en-US" sz="1550" dirty="0">
                 <a:solidFill>
                   <a:srgbClr val="002050"/>
                 </a:solidFill>
@@ -8727,7 +8727,7 @@
               </a:rPr>
               <a:t>Overall status amber. Planned: 40 pilot laptops. Completed: 34 upgraded, 3 deferred for application compatibility and 3 awaiting user availability. Main risk: the treasury spreadsheet add-in is not yet certified. Next step: submit the phase 2 go/no-go recommendation.</a:t>
             </a:r>
-            <a:endParaRPr lang="en-US" sz="1700" dirty="0"/>
+            <a:endParaRPr lang="en-US" sz="1900" dirty="0"/>
           </a:p>
         </p:txBody>
       </p:sp>
@@ -8813,7 +8813,7 @@
               <a:buNone/>
             </a:pPr>
             <a:r>
-              <a:rPr lang="en-US" sz="1700" b="1" dirty="0">
+              <a:rPr lang="en-US" sz="1900" b="1" dirty="0">
                 <a:solidFill>
                   <a:srgbClr val="002050"/>
                 </a:solidFill>
@@ -8831,7 +8831,7 @@
               <a:buNone/>
             </a:pPr>
             <a:r>
-              <a:rPr lang="en-US" sz="1400" dirty="0">
+              <a:rPr lang="en-US" sz="1550" dirty="0">
                 <a:solidFill>
                   <a:srgbClr val="002050"/>
                 </a:solidFill>
@@ -8841,7 +8841,7 @@
               </a:rPr>
               <a:t>Overall status green. Access points installed at 5 of 6 planned branches; the remaining branch is delayed by landlord access approval. Budget used: 71% against planned 75%. Next step: coverage tests and branch manager sign-off.</a:t>
             </a:r>
-            <a:endParaRPr lang="en-US" sz="1700" dirty="0"/>
+            <a:endParaRPr lang="en-US" sz="1900" dirty="0"/>
           </a:p>
         </p:txBody>
       </p:sp>
@@ -8983,8 +8983,8 @@
         </p:nvSpPr>
         <p:spPr>
           <a:xfrm>
-            <a:off x="502920" y="274320"/>
-            <a:ext cx="11183112" cy="329184"/>
+            <a:off x="502920" y="256032"/>
+            <a:ext cx="11183112" cy="347472"/>
           </a:xfrm>
           <a:prstGeom prst="rect">
             <a:avLst/>
@@ -9000,7 +9000,7 @@
               <a:buNone/>
             </a:pPr>
             <a:r>
-              <a:rPr lang="en-US" sz="1300" b="1" spc="200" kern="0" dirty="0">
+              <a:rPr lang="en-US" sz="1400" b="1" spc="200" kern="0" dirty="0">
                 <a:solidFill>
                   <a:srgbClr val="0F6CBD"/>
                 </a:solidFill>
@@ -9010,7 +9010,7 @@
               </a:rPr>
               <a:t>WORKED EXAMPLES · RECOMMENDATION</a:t>
             </a:r>
-            <a:endParaRPr lang="en-US" sz="1300" dirty="0"/>
+            <a:endParaRPr lang="en-US" sz="1400" dirty="0"/>
           </a:p>
         </p:txBody>
       </p:sp>
@@ -9022,8 +9022,8 @@
         </p:nvSpPr>
         <p:spPr>
           <a:xfrm>
-            <a:off x="502920" y="603504"/>
-            <a:ext cx="11183112" cy="749808"/>
+            <a:off x="502920" y="585216"/>
+            <a:ext cx="11183112" cy="786384"/>
           </a:xfrm>
           <a:prstGeom prst="rect">
             <a:avLst/>
@@ -9039,7 +9039,7 @@
               <a:buNone/>
             </a:pPr>
             <a:r>
-              <a:rPr lang="en-US" sz="3100" b="1" dirty="0">
+              <a:rPr lang="en-US" sz="3400" b="1" dirty="0">
                 <a:solidFill>
                   <a:srgbClr val="002050"/>
                 </a:solidFill>
@@ -9049,7 +9049,7 @@
               </a:rPr>
               <a:t>Sample Recommendation Report</a:t>
             </a:r>
-            <a:endParaRPr lang="en-US" sz="3100" dirty="0"/>
+            <a:endParaRPr lang="en-US" sz="3400" dirty="0"/>
           </a:p>
         </p:txBody>
       </p:sp>
@@ -9078,7 +9078,7 @@
               <a:buNone/>
             </a:pPr>
             <a:r>
-              <a:rPr lang="en-US" sz="1500" dirty="0">
+              <a:rPr lang="en-US" sz="1650" dirty="0">
                 <a:solidFill>
                   <a:srgbClr val="6B7280"/>
                 </a:solidFill>
@@ -9088,7 +9088,7 @@
               </a:rPr>
               <a:t>Recommendation reports answer: Which option should management approve, why, by when, and at what cost or risk?</a:t>
             </a:r>
-            <a:endParaRPr lang="en-US" sz="1500" dirty="0"/>
+            <a:endParaRPr lang="en-US" sz="1650" dirty="0"/>
           </a:p>
         </p:txBody>
       </p:sp>
@@ -9174,7 +9174,7 @@
               <a:buNone/>
             </a:pPr>
             <a:r>
-              <a:rPr lang="en-US" sz="1650" b="1" dirty="0">
+              <a:rPr lang="en-US" sz="1800" b="1" dirty="0">
                 <a:solidFill>
                   <a:srgbClr val="002050"/>
                 </a:solidFill>
@@ -9191,7 +9191,7 @@
               <a:buNone/>
             </a:pPr>
             <a:r>
-              <a:rPr lang="en-US" sz="1550" dirty="0">
+              <a:rPr lang="en-US" sz="1700" dirty="0">
                 <a:solidFill>
                   <a:srgbClr val="002050"/>
                 </a:solidFill>
@@ -9201,7 +9201,7 @@
               </a:rPr>
               <a:t>Implement a searchable knowledge base for recurring support issues by 30 November 2026.</a:t>
             </a:r>
-            <a:endParaRPr lang="en-US" sz="1650" dirty="0"/>
+            <a:endParaRPr lang="en-US" sz="1800" dirty="0"/>
           </a:p>
         </p:txBody>
       </p:sp>
@@ -9287,7 +9287,7 @@
               <a:buNone/>
             </a:pPr>
             <a:r>
-              <a:rPr lang="en-US" sz="1750" b="1" dirty="0">
+              <a:rPr lang="en-US" sz="1900" b="1" dirty="0">
                 <a:solidFill>
                   <a:srgbClr val="002050"/>
                 </a:solidFill>
@@ -9305,7 +9305,7 @@
               <a:buNone/>
             </a:pPr>
             <a:r>
-              <a:rPr lang="en-US" sz="1400" dirty="0">
+              <a:rPr lang="en-US" sz="1550" dirty="0">
                 <a:solidFill>
                   <a:srgbClr val="002050"/>
                 </a:solidFill>
@@ -9315,7 +9315,7 @@
               </a:rPr>
               <a:t>Password resets, VPN setup, printer mapping and Teams audio issues account for 41% of first-line requests.</a:t>
             </a:r>
-            <a:endParaRPr lang="en-US" sz="1750" dirty="0"/>
+            <a:endParaRPr lang="en-US" sz="1900" dirty="0"/>
           </a:p>
         </p:txBody>
       </p:sp>
@@ -9401,7 +9401,7 @@
               <a:buNone/>
             </a:pPr>
             <a:r>
-              <a:rPr lang="en-US" sz="1750" b="1" dirty="0">
+              <a:rPr lang="en-US" sz="1900" b="1" dirty="0">
                 <a:solidFill>
                   <a:srgbClr val="002050"/>
                 </a:solidFill>
@@ -9419,7 +9419,7 @@
               <a:buNone/>
             </a:pPr>
             <a:r>
-              <a:rPr lang="en-US" sz="1400" dirty="0">
+              <a:rPr lang="en-US" sz="1550" dirty="0">
                 <a:solidFill>
                   <a:srgbClr val="002050"/>
                 </a:solidFill>
@@ -9429,7 +9429,7 @@
               </a:rPr>
               <a:t>Use the existing ITSM knowledge module because it avoids new licensing costs, supports approval workflows and links articles directly to tickets.</a:t>
             </a:r>
-            <a:endParaRPr lang="en-US" sz="1750" dirty="0"/>
+            <a:endParaRPr lang="en-US" sz="1900" dirty="0"/>
           </a:p>
         </p:txBody>
       </p:sp>
@@ -9515,7 +9515,7 @@
               <a:buNone/>
             </a:pPr>
             <a:r>
-              <a:rPr lang="en-US" sz="1750" b="1" dirty="0">
+              <a:rPr lang="en-US" sz="1900" b="1" dirty="0">
                 <a:solidFill>
                   <a:srgbClr val="002050"/>
                 </a:solidFill>
@@ -9533,7 +9533,7 @@
               <a:buNone/>
             </a:pPr>
             <a:r>
-              <a:rPr lang="en-US" sz="1400" dirty="0">
+              <a:rPr lang="en-US" sz="1550" dirty="0">
                 <a:solidFill>
                   <a:srgbClr val="002050"/>
                 </a:solidFill>
@@ -9543,7 +9543,7 @@
               </a:rPr>
               <a:t>Assign two analysts for article creation and require monthly review by team leads.</a:t>
             </a:r>
-            <a:endParaRPr lang="en-US" sz="1750" dirty="0"/>
+            <a:endParaRPr lang="en-US" sz="1900" dirty="0"/>
           </a:p>
         </p:txBody>
       </p:sp>
@@ -9685,8 +9685,8 @@
         </p:nvSpPr>
         <p:spPr>
           <a:xfrm>
-            <a:off x="502920" y="274320"/>
-            <a:ext cx="11183112" cy="329184"/>
+            <a:off x="502920" y="256032"/>
+            <a:ext cx="11183112" cy="347472"/>
           </a:xfrm>
           <a:prstGeom prst="rect">
             <a:avLst/>
@@ -9702,7 +9702,7 @@
               <a:buNone/>
             </a:pPr>
             <a:r>
-              <a:rPr lang="en-US" sz="1300" b="1" spc="200" kern="0" dirty="0">
+              <a:rPr lang="en-US" sz="1400" b="1" spc="200" kern="0" dirty="0">
                 <a:solidFill>
                   <a:srgbClr val="0F6CBD"/>
                 </a:solidFill>
@@ -9712,7 +9712,7 @@
               </a:rPr>
               <a:t>OBTAINING &amp; DISTRIBUTING INFORMATION</a:t>
             </a:r>
-            <a:endParaRPr lang="en-US" sz="1300" dirty="0"/>
+            <a:endParaRPr lang="en-US" sz="1400" dirty="0"/>
           </a:p>
         </p:txBody>
       </p:sp>
@@ -9724,8 +9724,8 @@
         </p:nvSpPr>
         <p:spPr>
           <a:xfrm>
-            <a:off x="502920" y="603504"/>
-            <a:ext cx="11183112" cy="749808"/>
+            <a:off x="502920" y="585216"/>
+            <a:ext cx="11183112" cy="786384"/>
           </a:xfrm>
           <a:prstGeom prst="rect">
             <a:avLst/>
@@ -9741,7 +9741,7 @@
               <a:buNone/>
             </a:pPr>
             <a:r>
-              <a:rPr lang="en-US" sz="3100" b="1" dirty="0">
+              <a:rPr lang="en-US" sz="3400" b="1" dirty="0">
                 <a:solidFill>
                   <a:srgbClr val="002050"/>
                 </a:solidFill>
@@ -9751,7 +9751,7 @@
               </a:rPr>
               <a:t>Resources for Getting Information</a:t>
             </a:r>
-            <a:endParaRPr lang="en-US" sz="3100" dirty="0"/>
+            <a:endParaRPr lang="en-US" sz="3400" dirty="0"/>
           </a:p>
         </p:txBody>
       </p:sp>
@@ -9786,7 +9786,7 @@
               <a:buNone/>
             </a:pPr>
             <a:r>
-              <a:rPr lang="en-US" sz="1700" dirty="0">
+              <a:rPr lang="en-US" sz="1900" dirty="0">
                 <a:solidFill>
                   <a:srgbClr val="002050"/>
                 </a:solidFill>
@@ -9797,7 +9797,7 @@
               <a:t>Firstly, all information which is available in the organisation must always be seen as confidential information. When information is made available to competitors, they may gain the upper hand and copy concepts and ideas from the organisation — which could lead to serious financial implications.
 </a:t>
             </a:r>
-            <a:endParaRPr lang="en-US" sz="1700" dirty="0"/>
+            <a:endParaRPr lang="en-US" sz="1900" dirty="0"/>
           </a:p>
           <a:p>
             <a:pPr indent="0" marL="0">
@@ -9810,7 +9810,7 @@
               <a:buNone/>
             </a:pPr>
             <a:r>
-              <a:rPr lang="en-US" sz="1700" dirty="0">
+              <a:rPr lang="en-US" sz="1900" dirty="0">
                 <a:solidFill>
                   <a:srgbClr val="002050"/>
                 </a:solidFill>
@@ -9820,7 +9820,7 @@
               </a:rPr>
               <a:t>Information centres in the organisation — such as operations, finance, research and development, and human resources — will have information about the organisation and will be able to give an authorised individual all the information they may need.</a:t>
             </a:r>
-            <a:endParaRPr lang="en-US" sz="1700" dirty="0"/>
+            <a:endParaRPr lang="en-US" sz="1900" dirty="0"/>
           </a:p>
         </p:txBody>
       </p:sp>
@@ -9992,8 +9992,8 @@
         </p:nvSpPr>
         <p:spPr>
           <a:xfrm>
-            <a:off x="502920" y="274320"/>
-            <a:ext cx="11183112" cy="329184"/>
+            <a:off x="502920" y="256032"/>
+            <a:ext cx="11183112" cy="347472"/>
           </a:xfrm>
           <a:prstGeom prst="rect">
             <a:avLst/>
@@ -10009,7 +10009,7 @@
               <a:buNone/>
             </a:pPr>
             <a:r>
-              <a:rPr lang="en-US" sz="1300" b="1" spc="200" kern="0" dirty="0">
+              <a:rPr lang="en-US" sz="1400" b="1" spc="200" kern="0" dirty="0">
                 <a:solidFill>
                   <a:srgbClr val="0F6CBD"/>
                 </a:solidFill>
@@ -10019,7 +10019,7 @@
               </a:rPr>
               <a:t>OBTAINING &amp; DISTRIBUTING INFORMATION</a:t>
             </a:r>
-            <a:endParaRPr lang="en-US" sz="1300" dirty="0"/>
+            <a:endParaRPr lang="en-US" sz="1400" dirty="0"/>
           </a:p>
         </p:txBody>
       </p:sp>
@@ -10031,8 +10031,8 @@
         </p:nvSpPr>
         <p:spPr>
           <a:xfrm>
-            <a:off x="502920" y="603504"/>
-            <a:ext cx="11183112" cy="749808"/>
+            <a:off x="502920" y="585216"/>
+            <a:ext cx="11183112" cy="786384"/>
           </a:xfrm>
           <a:prstGeom prst="rect">
             <a:avLst/>
@@ -10048,7 +10048,7 @@
               <a:buNone/>
             </a:pPr>
             <a:r>
-              <a:rPr lang="en-US" sz="3100" b="1" dirty="0">
+              <a:rPr lang="en-US" sz="3400" b="1" dirty="0">
                 <a:solidFill>
                   <a:srgbClr val="002050"/>
                 </a:solidFill>
@@ -10058,7 +10058,7 @@
               </a:rPr>
               <a:t>Information Sourced From the Organisation</a:t>
             </a:r>
-            <a:endParaRPr lang="en-US" sz="3100" dirty="0"/>
+            <a:endParaRPr lang="en-US" sz="3400" dirty="0"/>
           </a:p>
         </p:txBody>
       </p:sp>
@@ -10093,7 +10093,7 @@
               <a:buNone/>
             </a:pPr>
             <a:r>
-              <a:rPr lang="en-US" sz="1750" dirty="0">
+              <a:rPr lang="en-US" sz="1950" dirty="0">
                 <a:solidFill>
                   <a:srgbClr val="002050"/>
                 </a:solidFill>
@@ -10104,7 +10104,7 @@
               <a:t>Information can include, but is not limited to:
 </a:t>
             </a:r>
-            <a:endParaRPr lang="en-US" sz="1750" dirty="0"/>
+            <a:endParaRPr lang="en-US" sz="1950" dirty="0"/>
           </a:p>
           <a:p>
             <a:pPr marL="228600" indent="-228600">
@@ -10118,7 +10118,7 @@
               <a:buChar char="•"/>
             </a:pPr>
             <a:r>
-              <a:rPr lang="en-US" sz="1750" dirty="0">
+              <a:rPr lang="en-US" sz="1950" dirty="0">
                 <a:solidFill>
                   <a:srgbClr val="002050"/>
                 </a:solidFill>
@@ -10128,7 +10128,7 @@
               </a:rPr>
               <a:t>Financial statements / reports</a:t>
             </a:r>
-            <a:endParaRPr lang="en-US" sz="1750" dirty="0"/>
+            <a:endParaRPr lang="en-US" sz="1950" dirty="0"/>
           </a:p>
           <a:p>
             <a:pPr marL="228600" indent="-228600">
@@ -10142,7 +10142,7 @@
               <a:buChar char="•"/>
             </a:pPr>
             <a:r>
-              <a:rPr lang="en-US" sz="1750" dirty="0">
+              <a:rPr lang="en-US" sz="1950" dirty="0">
                 <a:solidFill>
                   <a:srgbClr val="002050"/>
                 </a:solidFill>
@@ -10152,7 +10152,7 @@
               </a:rPr>
               <a:t>Research and development activities</a:t>
             </a:r>
-            <a:endParaRPr lang="en-US" sz="1750" dirty="0"/>
+            <a:endParaRPr lang="en-US" sz="1950" dirty="0"/>
           </a:p>
           <a:p>
             <a:pPr marL="228600" indent="-228600">
@@ -10166,7 +10166,7 @@
               <a:buChar char="•"/>
             </a:pPr>
             <a:r>
-              <a:rPr lang="en-US" sz="1750" dirty="0">
+              <a:rPr lang="en-US" sz="1950" dirty="0">
                 <a:solidFill>
                   <a:srgbClr val="002050"/>
                 </a:solidFill>
@@ -10176,7 +10176,7 @@
               </a:rPr>
               <a:t>Marketing and advertising strategies</a:t>
             </a:r>
-            <a:endParaRPr lang="en-US" sz="1750" dirty="0"/>
+            <a:endParaRPr lang="en-US" sz="1950" dirty="0"/>
           </a:p>
           <a:p>
             <a:pPr marL="228600" indent="-228600">
@@ -10190,7 +10190,7 @@
               <a:buChar char="•"/>
             </a:pPr>
             <a:r>
-              <a:rPr lang="en-US" sz="1750" dirty="0">
+              <a:rPr lang="en-US" sz="1950" dirty="0">
                 <a:solidFill>
                   <a:srgbClr val="002050"/>
                 </a:solidFill>
@@ -10200,7 +10200,7 @@
               </a:rPr>
               <a:t>Human resource needs / expectations</a:t>
             </a:r>
-            <a:endParaRPr lang="en-US" sz="1750" dirty="0"/>
+            <a:endParaRPr lang="en-US" sz="1950" dirty="0"/>
           </a:p>
           <a:p>
             <a:pPr marL="228600" indent="-228600">
@@ -10214,7 +10214,7 @@
               <a:buChar char="•"/>
             </a:pPr>
             <a:r>
-              <a:rPr lang="en-US" sz="1750" dirty="0">
+              <a:rPr lang="en-US" sz="1950" dirty="0">
                 <a:solidFill>
                   <a:srgbClr val="002050"/>
                 </a:solidFill>
@@ -10224,7 +10224,7 @@
               </a:rPr>
               <a:t>Company vision regarding the long-term expectations and future of the organisation</a:t>
             </a:r>
-            <a:endParaRPr lang="en-US" sz="1750" dirty="0"/>
+            <a:endParaRPr lang="en-US" sz="1950" dirty="0"/>
           </a:p>
           <a:p>
             <a:pPr marL="228600" indent="-228600">
@@ -10238,7 +10238,7 @@
               <a:buChar char="•"/>
             </a:pPr>
             <a:r>
-              <a:rPr lang="en-US" sz="1750" dirty="0">
+              <a:rPr lang="en-US" sz="1950" dirty="0">
                 <a:solidFill>
                   <a:srgbClr val="002050"/>
                 </a:solidFill>
@@ -10248,7 +10248,7 @@
               </a:rPr>
               <a:t>Project-specific information of certain aspects of projects undertaken by the organisation</a:t>
             </a:r>
-            <a:endParaRPr lang="en-US" sz="1750" dirty="0"/>
+            <a:endParaRPr lang="en-US" sz="1950" dirty="0"/>
           </a:p>
         </p:txBody>
       </p:sp>
@@ -10390,8 +10390,8 @@
         </p:nvSpPr>
         <p:spPr>
           <a:xfrm>
-            <a:off x="502920" y="274320"/>
-            <a:ext cx="11183112" cy="329184"/>
+            <a:off x="502920" y="256032"/>
+            <a:ext cx="11183112" cy="347472"/>
           </a:xfrm>
           <a:prstGeom prst="rect">
             <a:avLst/>
@@ -10407,7 +10407,7 @@
               <a:buNone/>
             </a:pPr>
             <a:r>
-              <a:rPr lang="en-US" sz="1300" b="1" spc="200" kern="0" dirty="0">
+              <a:rPr lang="en-US" sz="1400" b="1" spc="200" kern="0" dirty="0">
                 <a:solidFill>
                   <a:srgbClr val="0F6CBD"/>
                 </a:solidFill>
@@ -10417,7 +10417,7 @@
               </a:rPr>
               <a:t>LEARNER GUIDE CONTENTS</a:t>
             </a:r>
-            <a:endParaRPr lang="en-US" sz="1300" dirty="0"/>
+            <a:endParaRPr lang="en-US" sz="1400" dirty="0"/>
           </a:p>
         </p:txBody>
       </p:sp>
@@ -10429,8 +10429,8 @@
         </p:nvSpPr>
         <p:spPr>
           <a:xfrm>
-            <a:off x="502920" y="603504"/>
-            <a:ext cx="11183112" cy="749808"/>
+            <a:off x="502920" y="585216"/>
+            <a:ext cx="11183112" cy="786384"/>
           </a:xfrm>
           <a:prstGeom prst="rect">
             <a:avLst/>
@@ -10446,7 +10446,7 @@
               <a:buNone/>
             </a:pPr>
             <a:r>
-              <a:rPr lang="en-US" sz="3100" b="1" dirty="0">
+              <a:rPr lang="en-US" sz="3400" b="1" dirty="0">
                 <a:solidFill>
                   <a:srgbClr val="002050"/>
                 </a:solidFill>
@@ -10456,7 +10456,7 @@
               </a:rPr>
               <a:t>Competence Requirements</a:t>
             </a:r>
-            <a:endParaRPr lang="en-US" sz="3100" dirty="0"/>
+            <a:endParaRPr lang="en-US" sz="3400" dirty="0"/>
           </a:p>
         </p:txBody>
       </p:sp>
@@ -10487,7 +10487,7 @@
                 <a:gridCol w="6949440"/>
                 <a:gridCol w="941832"/>
               </a:tblGrid>
-              <a:tr h="658368">
+              <a:tr h="713232">
                 <a:tc>
                   <a:txBody>
                     <a:bodyPr/>
@@ -10497,7 +10497,7 @@
                         <a:buNone/>
                       </a:pPr>
                       <a:r>
-                        <a:rPr lang="en-US" sz="1500" b="1" dirty="0">
+                        <a:rPr lang="en-US" sz="1650" b="1" dirty="0">
                           <a:solidFill>
                             <a:srgbClr val="FFFFFF"/>
                           </a:solidFill>
@@ -10507,7 +10507,7 @@
                         </a:rPr>
                         <a:t>Section</a:t>
                       </a:r>
-                      <a:endParaRPr lang="en-US" sz="1500" dirty="0">
+                      <a:endParaRPr lang="en-US" sz="1650" dirty="0">
                         <a:latin typeface="Aptos Display" charset="0"/>
                         <a:ea typeface="Aptos Display" charset="0"/>
                         <a:cs typeface="Aptos Display" charset="0"/>
@@ -10565,7 +10565,7 @@
                         <a:buNone/>
                       </a:pPr>
                       <a:r>
-                        <a:rPr lang="en-US" sz="1500" b="1" dirty="0">
+                        <a:rPr lang="en-US" sz="1650" b="1" dirty="0">
                           <a:solidFill>
                             <a:srgbClr val="FFFFFF"/>
                           </a:solidFill>
@@ -10575,7 +10575,7 @@
                         </a:rPr>
                         <a:t>What it covers</a:t>
                       </a:r>
-                      <a:endParaRPr lang="en-US" sz="1500" dirty="0">
+                      <a:endParaRPr lang="en-US" sz="1650" dirty="0">
                         <a:latin typeface="Aptos Display" charset="0"/>
                         <a:ea typeface="Aptos Display" charset="0"/>
                         <a:cs typeface="Aptos Display" charset="0"/>
@@ -10633,7 +10633,7 @@
                         <a:buNone/>
                       </a:pPr>
                       <a:r>
-                        <a:rPr lang="en-US" sz="1500" b="1" dirty="0">
+                        <a:rPr lang="en-US" sz="1650" b="1" dirty="0">
                           <a:solidFill>
                             <a:srgbClr val="FFFFFF"/>
                           </a:solidFill>
@@ -10643,7 +10643,7 @@
                         </a:rPr>
                         <a:t>Page</a:t>
                       </a:r>
-                      <a:endParaRPr lang="en-US" sz="1500" dirty="0">
+                      <a:endParaRPr lang="en-US" sz="1650" dirty="0">
                         <a:latin typeface="Aptos Display" charset="0"/>
                         <a:ea typeface="Aptos Display" charset="0"/>
                         <a:cs typeface="Aptos Display" charset="0"/>
@@ -10693,7 +10693,7 @@
                   </a:tcPr>
                 </a:tc>
               </a:tr>
-              <a:tr h="658368">
+              <a:tr h="713232">
                 <a:tc>
                   <a:txBody>
                     <a:bodyPr/>
@@ -10703,7 +10703,7 @@
                         <a:buNone/>
                       </a:pPr>
                       <a:r>
-                        <a:rPr lang="en-US" sz="1500" dirty="0">
+                        <a:rPr lang="en-US" sz="1650" dirty="0">
                           <a:solidFill>
                             <a:srgbClr val="002050"/>
                           </a:solidFill>
@@ -10713,7 +10713,7 @@
                         </a:rPr>
                         <a:t>Alignment index</a:t>
                       </a:r>
-                      <a:endParaRPr lang="en-US" sz="1500" dirty="0">
+                      <a:endParaRPr lang="en-US" sz="1650" dirty="0">
                         <a:latin typeface="Aptos" charset="0"/>
                         <a:ea typeface="Aptos" charset="0"/>
                         <a:cs typeface="Aptos" charset="0"/>
@@ -10771,7 +10771,7 @@
                         <a:buNone/>
                       </a:pPr>
                       <a:r>
-                        <a:rPr lang="en-US" sz="1500" dirty="0">
+                        <a:rPr lang="en-US" sz="1650" dirty="0">
                           <a:solidFill>
                             <a:srgbClr val="002050"/>
                           </a:solidFill>
@@ -10781,7 +10781,7 @@
                         </a:rPr>
                         <a:t>The different outcomes you must prove competent in to complete US 8252</a:t>
                       </a:r>
-                      <a:endParaRPr lang="en-US" sz="1500" dirty="0">
+                      <a:endParaRPr lang="en-US" sz="1650" dirty="0">
                         <a:latin typeface="Aptos" charset="0"/>
                         <a:ea typeface="Aptos" charset="0"/>
                         <a:cs typeface="Aptos" charset="0"/>
@@ -10839,7 +10839,7 @@
                         <a:buNone/>
                       </a:pPr>
                       <a:r>
-                        <a:rPr lang="en-US" sz="1500" dirty="0">
+                        <a:rPr lang="en-US" sz="1650" dirty="0">
                           <a:solidFill>
                             <a:srgbClr val="002050"/>
                           </a:solidFill>
@@ -10849,7 +10849,7 @@
                         </a:rPr>
                         <a:t>3</a:t>
                       </a:r>
-                      <a:endParaRPr lang="en-US" sz="1500" dirty="0">
+                      <a:endParaRPr lang="en-US" sz="1650" dirty="0">
                         <a:latin typeface="Aptos" charset="0"/>
                         <a:ea typeface="Aptos" charset="0"/>
                         <a:cs typeface="Aptos" charset="0"/>
@@ -10899,7 +10899,7 @@
                   </a:tcPr>
                 </a:tc>
               </a:tr>
-              <a:tr h="658368">
+              <a:tr h="713232">
                 <a:tc>
                   <a:txBody>
                     <a:bodyPr/>
@@ -10909,7 +10909,7 @@
                         <a:buNone/>
                       </a:pPr>
                       <a:r>
-                        <a:rPr lang="en-US" sz="1500" dirty="0">
+                        <a:rPr lang="en-US" sz="1650" dirty="0">
                           <a:solidFill>
                             <a:srgbClr val="002050"/>
                           </a:solidFill>
@@ -10919,7 +10919,7 @@
                         </a:rPr>
                         <a:t>Purpose &amp; content of reports</a:t>
                       </a:r>
-                      <a:endParaRPr lang="en-US" sz="1500" dirty="0">
+                      <a:endParaRPr lang="en-US" sz="1650" dirty="0">
                         <a:latin typeface="Aptos" charset="0"/>
                         <a:ea typeface="Aptos" charset="0"/>
                         <a:cs typeface="Aptos" charset="0"/>
@@ -10977,7 +10977,7 @@
                         <a:buNone/>
                       </a:pPr>
                       <a:r>
-                        <a:rPr lang="en-US" sz="1500" dirty="0">
+                        <a:rPr lang="en-US" sz="1650" dirty="0">
                           <a:solidFill>
                             <a:srgbClr val="002050"/>
                           </a:solidFill>
@@ -10987,7 +10987,7 @@
                         </a:rPr>
                         <a:t>The various types of reports, their purposes and the range of information in them</a:t>
                       </a:r>
-                      <a:endParaRPr lang="en-US" sz="1500" dirty="0">
+                      <a:endParaRPr lang="en-US" sz="1650" dirty="0">
                         <a:latin typeface="Aptos" charset="0"/>
                         <a:ea typeface="Aptos" charset="0"/>
                         <a:cs typeface="Aptos" charset="0"/>
@@ -11045,7 +11045,7 @@
                         <a:buNone/>
                       </a:pPr>
                       <a:r>
-                        <a:rPr lang="en-US" sz="1500" dirty="0">
+                        <a:rPr lang="en-US" sz="1650" dirty="0">
                           <a:solidFill>
                             <a:srgbClr val="002050"/>
                           </a:solidFill>
@@ -11055,7 +11055,7 @@
                         </a:rPr>
                         <a:t>4</a:t>
                       </a:r>
-                      <a:endParaRPr lang="en-US" sz="1500" dirty="0">
+                      <a:endParaRPr lang="en-US" sz="1650" dirty="0">
                         <a:latin typeface="Aptos" charset="0"/>
                         <a:ea typeface="Aptos" charset="0"/>
                         <a:cs typeface="Aptos" charset="0"/>
@@ -11105,7 +11105,7 @@
                   </a:tcPr>
                 </a:tc>
               </a:tr>
-              <a:tr h="658368">
+              <a:tr h="713232">
                 <a:tc>
                   <a:txBody>
                     <a:bodyPr/>
@@ -11115,7 +11115,7 @@
                         <a:buNone/>
                       </a:pPr>
                       <a:r>
-                        <a:rPr lang="en-US" sz="1500" dirty="0">
+                        <a:rPr lang="en-US" sz="1650" dirty="0">
                           <a:solidFill>
                             <a:srgbClr val="002050"/>
                           </a:solidFill>
@@ -11125,7 +11125,7 @@
                         </a:rPr>
                         <a:t>Obtaining &amp; distributing information</a:t>
                       </a:r>
-                      <a:endParaRPr lang="en-US" sz="1500" dirty="0">
+                      <a:endParaRPr lang="en-US" sz="1650" dirty="0">
                         <a:latin typeface="Aptos" charset="0"/>
                         <a:ea typeface="Aptos" charset="0"/>
                         <a:cs typeface="Aptos" charset="0"/>
@@ -11183,7 +11183,7 @@
                         <a:buNone/>
                       </a:pPr>
                       <a:r>
-                        <a:rPr lang="en-US" sz="1500" dirty="0">
+                        <a:rPr lang="en-US" sz="1650" dirty="0">
                           <a:solidFill>
                             <a:srgbClr val="002050"/>
                           </a:solidFill>
@@ -11193,7 +11193,7 @@
                         </a:rPr>
                         <a:t>The resources used to obtain information and the methods for distributing reports</a:t>
                       </a:r>
-                      <a:endParaRPr lang="en-US" sz="1500" dirty="0">
+                      <a:endParaRPr lang="en-US" sz="1650" dirty="0">
                         <a:latin typeface="Aptos" charset="0"/>
                         <a:ea typeface="Aptos" charset="0"/>
                         <a:cs typeface="Aptos" charset="0"/>
@@ -11251,7 +11251,7 @@
                         <a:buNone/>
                       </a:pPr>
                       <a:r>
-                        <a:rPr lang="en-US" sz="1500" dirty="0">
+                        <a:rPr lang="en-US" sz="1650" dirty="0">
                           <a:solidFill>
                             <a:srgbClr val="002050"/>
                           </a:solidFill>
@@ -11261,7 +11261,7 @@
                         </a:rPr>
                         <a:t>8</a:t>
                       </a:r>
-                      <a:endParaRPr lang="en-US" sz="1500" dirty="0">
+                      <a:endParaRPr lang="en-US" sz="1650" dirty="0">
                         <a:latin typeface="Aptos" charset="0"/>
                         <a:ea typeface="Aptos" charset="0"/>
                         <a:cs typeface="Aptos" charset="0"/>
@@ -11311,7 +11311,7 @@
                   </a:tcPr>
                 </a:tc>
               </a:tr>
-              <a:tr h="658368">
+              <a:tr h="713232">
                 <a:tc>
                   <a:txBody>
                     <a:bodyPr/>
@@ -11321,7 +11321,7 @@
                         <a:buNone/>
                       </a:pPr>
                       <a:r>
-                        <a:rPr lang="en-US" sz="1500" dirty="0">
+                        <a:rPr lang="en-US" sz="1650" dirty="0">
                           <a:solidFill>
                             <a:srgbClr val="002050"/>
                           </a:solidFill>
@@ -11331,7 +11331,7 @@
                         </a:rPr>
                         <a:t>Verifying reported information</a:t>
                       </a:r>
-                      <a:endParaRPr lang="en-US" sz="1500" dirty="0">
+                      <a:endParaRPr lang="en-US" sz="1650" dirty="0">
                         <a:latin typeface="Aptos" charset="0"/>
                         <a:ea typeface="Aptos" charset="0"/>
                         <a:cs typeface="Aptos" charset="0"/>
@@ -11389,7 +11389,7 @@
                         <a:buNone/>
                       </a:pPr>
                       <a:r>
-                        <a:rPr lang="en-US" sz="1500" dirty="0">
+                        <a:rPr lang="en-US" sz="1650" dirty="0">
                           <a:solidFill>
                             <a:srgbClr val="002050"/>
                           </a:solidFill>
@@ -11399,7 +11399,7 @@
                         </a:rPr>
                         <a:t>How report information is checked against requirements and approved for distribution</a:t>
                       </a:r>
-                      <a:endParaRPr lang="en-US" sz="1500" dirty="0">
+                      <a:endParaRPr lang="en-US" sz="1650" dirty="0">
                         <a:latin typeface="Aptos" charset="0"/>
                         <a:ea typeface="Aptos" charset="0"/>
                         <a:cs typeface="Aptos" charset="0"/>
@@ -11457,7 +11457,7 @@
                         <a:buNone/>
                       </a:pPr>
                       <a:r>
-                        <a:rPr lang="en-US" sz="1500" dirty="0">
+                        <a:rPr lang="en-US" sz="1650" dirty="0">
                           <a:solidFill>
                             <a:srgbClr val="002050"/>
                           </a:solidFill>
@@ -11467,7 +11467,7 @@
                         </a:rPr>
                         <a:t>9</a:t>
                       </a:r>
-                      <a:endParaRPr lang="en-US" sz="1500" dirty="0">
+                      <a:endParaRPr lang="en-US" sz="1650" dirty="0">
                         <a:latin typeface="Aptos" charset="0"/>
                         <a:ea typeface="Aptos" charset="0"/>
                         <a:cs typeface="Aptos" charset="0"/>
@@ -11517,7 +11517,7 @@
                   </a:tcPr>
                 </a:tc>
               </a:tr>
-              <a:tr h="658368">
+              <a:tr h="713232">
                 <a:tc>
                   <a:txBody>
                     <a:bodyPr/>
@@ -11527,7 +11527,7 @@
                         <a:buNone/>
                       </a:pPr>
                       <a:r>
-                        <a:rPr lang="en-US" sz="1500" dirty="0">
+                        <a:rPr lang="en-US" sz="1650" dirty="0">
                           <a:solidFill>
                             <a:srgbClr val="002050"/>
                           </a:solidFill>
@@ -11537,7 +11537,7 @@
                         </a:rPr>
                         <a:t>Question Session 1</a:t>
                       </a:r>
-                      <a:endParaRPr lang="en-US" sz="1500" dirty="0">
+                      <a:endParaRPr lang="en-US" sz="1650" dirty="0">
                         <a:latin typeface="Aptos" charset="0"/>
                         <a:ea typeface="Aptos" charset="0"/>
                         <a:cs typeface="Aptos" charset="0"/>
@@ -11595,7 +11595,7 @@
                         <a:buNone/>
                       </a:pPr>
                       <a:r>
-                        <a:rPr lang="en-US" sz="1500" dirty="0">
+                        <a:rPr lang="en-US" sz="1650" dirty="0">
                           <a:solidFill>
                             <a:srgbClr val="002050"/>
                           </a:solidFill>
@@ -11605,7 +11605,7 @@
                         </a:rPr>
                         <a:t>Your knowledge of this section is assessed with the questions</a:t>
                       </a:r>
-                      <a:endParaRPr lang="en-US" sz="1500" dirty="0">
+                      <a:endParaRPr lang="en-US" sz="1650" dirty="0">
                         <a:latin typeface="Aptos" charset="0"/>
                         <a:ea typeface="Aptos" charset="0"/>
                         <a:cs typeface="Aptos" charset="0"/>
@@ -11663,7 +11663,7 @@
                         <a:buNone/>
                       </a:pPr>
                       <a:r>
-                        <a:rPr lang="en-US" sz="1500" dirty="0">
+                        <a:rPr lang="en-US" sz="1650" dirty="0">
                           <a:solidFill>
                             <a:srgbClr val="002050"/>
                           </a:solidFill>
@@ -11673,7 +11673,7 @@
                         </a:rPr>
                         <a:t>10</a:t>
                       </a:r>
-                      <a:endParaRPr lang="en-US" sz="1500" dirty="0">
+                      <a:endParaRPr lang="en-US" sz="1650" dirty="0">
                         <a:latin typeface="Aptos" charset="0"/>
                         <a:ea typeface="Aptos" charset="0"/>
                         <a:cs typeface="Aptos" charset="0"/>
@@ -11723,7 +11723,7 @@
                   </a:tcPr>
                 </a:tc>
               </a:tr>
-              <a:tr h="658368">
+              <a:tr h="713232">
                 <a:tc>
                   <a:txBody>
                     <a:bodyPr/>
@@ -11733,7 +11733,7 @@
                         <a:buNone/>
                       </a:pPr>
                       <a:r>
-                        <a:rPr lang="en-US" sz="1500" dirty="0">
+                        <a:rPr lang="en-US" sz="1650" dirty="0">
                           <a:solidFill>
                             <a:srgbClr val="002050"/>
                           </a:solidFill>
@@ -11743,7 +11743,7 @@
                         </a:rPr>
                         <a:t>Self-assessment</a:t>
                       </a:r>
-                      <a:endParaRPr lang="en-US" sz="1500" dirty="0">
+                      <a:endParaRPr lang="en-US" sz="1650" dirty="0">
                         <a:latin typeface="Aptos" charset="0"/>
                         <a:ea typeface="Aptos" charset="0"/>
                         <a:cs typeface="Aptos" charset="0"/>
@@ -11801,7 +11801,7 @@
                         <a:buNone/>
                       </a:pPr>
                       <a:r>
-                        <a:rPr lang="en-US" sz="1500" dirty="0">
+                        <a:rPr lang="en-US" sz="1650" dirty="0">
                           <a:solidFill>
                             <a:srgbClr val="002050"/>
                           </a:solidFill>
@@ -11811,7 +11811,7 @@
                         </a:rPr>
                         <a:t>Check the progress you have made and arrange support to become competent</a:t>
                       </a:r>
-                      <a:endParaRPr lang="en-US" sz="1500" dirty="0">
+                      <a:endParaRPr lang="en-US" sz="1650" dirty="0">
                         <a:latin typeface="Aptos" charset="0"/>
                         <a:ea typeface="Aptos" charset="0"/>
                         <a:cs typeface="Aptos" charset="0"/>
@@ -11869,7 +11869,7 @@
                         <a:buNone/>
                       </a:pPr>
                       <a:r>
-                        <a:rPr lang="en-US" sz="1500" dirty="0">
+                        <a:rPr lang="en-US" sz="1650" dirty="0">
                           <a:solidFill>
                             <a:srgbClr val="002050"/>
                           </a:solidFill>
@@ -11879,7 +11879,7 @@
                         </a:rPr>
                         <a:t>12</a:t>
                       </a:r>
-                      <a:endParaRPr lang="en-US" sz="1500" dirty="0">
+                      <a:endParaRPr lang="en-US" sz="1650" dirty="0">
                         <a:latin typeface="Aptos" charset="0"/>
                         <a:ea typeface="Aptos" charset="0"/>
                         <a:cs typeface="Aptos" charset="0"/>
@@ -12071,8 +12071,8 @@
         </p:nvSpPr>
         <p:spPr>
           <a:xfrm>
-            <a:off x="502920" y="274320"/>
-            <a:ext cx="11183112" cy="329184"/>
+            <a:off x="502920" y="256032"/>
+            <a:ext cx="11183112" cy="347472"/>
           </a:xfrm>
           <a:prstGeom prst="rect">
             <a:avLst/>
@@ -12088,7 +12088,7 @@
               <a:buNone/>
             </a:pPr>
             <a:r>
-              <a:rPr lang="en-US" sz="1300" b="1" spc="200" kern="0" dirty="0">
+              <a:rPr lang="en-US" sz="1400" b="1" spc="200" kern="0" dirty="0">
                 <a:solidFill>
                   <a:srgbClr val="0F6CBD"/>
                 </a:solidFill>
@@ -12098,7 +12098,7 @@
               </a:rPr>
               <a:t>OBTAINING &amp; DISTRIBUTING INFORMATION</a:t>
             </a:r>
-            <a:endParaRPr lang="en-US" sz="1300" dirty="0"/>
+            <a:endParaRPr lang="en-US" sz="1400" dirty="0"/>
           </a:p>
         </p:txBody>
       </p:sp>
@@ -12110,8 +12110,8 @@
         </p:nvSpPr>
         <p:spPr>
           <a:xfrm>
-            <a:off x="502920" y="603504"/>
-            <a:ext cx="11183112" cy="749808"/>
+            <a:off x="502920" y="585216"/>
+            <a:ext cx="11183112" cy="786384"/>
           </a:xfrm>
           <a:prstGeom prst="rect">
             <a:avLst/>
@@ -12127,7 +12127,7 @@
               <a:buNone/>
             </a:pPr>
             <a:r>
-              <a:rPr lang="en-US" sz="3100" b="1" dirty="0">
+              <a:rPr lang="en-US" sz="3400" b="1" dirty="0">
                 <a:solidFill>
                   <a:srgbClr val="002050"/>
                 </a:solidFill>
@@ -12137,7 +12137,7 @@
               </a:rPr>
               <a:t>Procedures for Distributing Information</a:t>
             </a:r>
-            <a:endParaRPr lang="en-US" sz="3100" dirty="0"/>
+            <a:endParaRPr lang="en-US" sz="3400" dirty="0"/>
           </a:p>
         </p:txBody>
       </p:sp>
@@ -12172,7 +12172,7 @@
               <a:buNone/>
             </a:pPr>
             <a:r>
-              <a:rPr lang="en-US" sz="1550" dirty="0">
+              <a:rPr lang="en-US" sz="1700" dirty="0">
                 <a:solidFill>
                   <a:srgbClr val="002050"/>
                 </a:solidFill>
@@ -12183,7 +12183,7 @@
               <a:t>Distributing information about the organisation must be handled in a very delicate manner and the recipients of such information must be selected carefully. Depending on the severity of the information and the level of security and/or risk attached to it, recipients should be graded on whether or not they are liable to obtain such information.
 </a:t>
             </a:r>
-            <a:endParaRPr lang="en-US" sz="1550" dirty="0"/>
+            <a:endParaRPr lang="en-US" sz="1700" dirty="0"/>
           </a:p>
           <a:p>
             <a:pPr indent="0" marL="0">
@@ -12196,7 +12196,7 @@
               <a:buNone/>
             </a:pPr>
             <a:r>
-              <a:rPr lang="en-US" sz="1550" dirty="0">
+              <a:rPr lang="en-US" sz="1700" dirty="0">
                 <a:solidFill>
                   <a:srgbClr val="002050"/>
                 </a:solidFill>
@@ -12207,7 +12207,7 @@
               <a:t>Most information will be distributed to individuals in the organisation depending on their need for it. The information should be relevant to their needs and their use.
 </a:t>
             </a:r>
-            <a:endParaRPr lang="en-US" sz="1550" dirty="0"/>
+            <a:endParaRPr lang="en-US" sz="1700" dirty="0"/>
           </a:p>
           <a:p>
             <a:pPr indent="0" marL="0">
@@ -12220,7 +12220,7 @@
               <a:buNone/>
             </a:pPr>
             <a:r>
-              <a:rPr lang="en-US" sz="1550" dirty="0">
+              <a:rPr lang="en-US" sz="1700" dirty="0">
                 <a:solidFill>
                   <a:srgbClr val="002050"/>
                 </a:solidFill>
@@ -12230,7 +12230,7 @@
               </a:rPr>
               <a:t>For example: if the marketing department is included in the distribution of a new marketing campaign, the information given to them should purely be on the new product/service and how it will influence and/or attract customers, including the expected target market. They need not know the amount spent on the research and development costs of the new product.</a:t>
             </a:r>
-            <a:endParaRPr lang="en-US" sz="1550" dirty="0"/>
+            <a:endParaRPr lang="en-US" sz="1700" dirty="0"/>
           </a:p>
         </p:txBody>
       </p:sp>
@@ -12372,8 +12372,8 @@
         </p:nvSpPr>
         <p:spPr>
           <a:xfrm>
-            <a:off x="502920" y="274320"/>
-            <a:ext cx="11183112" cy="329184"/>
+            <a:off x="502920" y="256032"/>
+            <a:ext cx="11183112" cy="347472"/>
           </a:xfrm>
           <a:prstGeom prst="rect">
             <a:avLst/>
@@ -12389,7 +12389,7 @@
               <a:buNone/>
             </a:pPr>
             <a:r>
-              <a:rPr lang="en-US" sz="1300" b="1" spc="200" kern="0" dirty="0">
+              <a:rPr lang="en-US" sz="1400" b="1" spc="200" kern="0" dirty="0">
                 <a:solidFill>
                   <a:srgbClr val="0F6CBD"/>
                 </a:solidFill>
@@ -12399,7 +12399,7 @@
               </a:rPr>
               <a:t>VERIFYING REPORTED INFORMATION</a:t>
             </a:r>
-            <a:endParaRPr lang="en-US" sz="1300" dirty="0"/>
+            <a:endParaRPr lang="en-US" sz="1400" dirty="0"/>
           </a:p>
         </p:txBody>
       </p:sp>
@@ -12411,8 +12411,8 @@
         </p:nvSpPr>
         <p:spPr>
           <a:xfrm>
-            <a:off x="502920" y="603504"/>
-            <a:ext cx="11183112" cy="749808"/>
+            <a:off x="502920" y="585216"/>
+            <a:ext cx="11183112" cy="786384"/>
           </a:xfrm>
           <a:prstGeom prst="rect">
             <a:avLst/>
@@ -12428,7 +12428,7 @@
               <a:buNone/>
             </a:pPr>
             <a:r>
-              <a:rPr lang="en-US" sz="3100" b="1" dirty="0">
+              <a:rPr lang="en-US" sz="3400" b="1" dirty="0">
                 <a:solidFill>
                   <a:srgbClr val="002050"/>
                 </a:solidFill>
@@ -12438,7 +12438,7 @@
               </a:rPr>
               <a:t>Verifying Reported Information</a:t>
             </a:r>
-            <a:endParaRPr lang="en-US" sz="3100" dirty="0"/>
+            <a:endParaRPr lang="en-US" sz="3400" dirty="0"/>
           </a:p>
         </p:txBody>
       </p:sp>
@@ -12473,7 +12473,7 @@
               <a:buNone/>
             </a:pPr>
             <a:r>
-              <a:rPr lang="en-US" sz="1450" dirty="0">
+              <a:rPr lang="en-US" sz="1600" dirty="0">
                 <a:solidFill>
                   <a:srgbClr val="002050"/>
                 </a:solidFill>
@@ -12484,7 +12484,7 @@
               <a:t>Before any report is sent to a person who will proof it and ensure it is correct, the originator is required to double-check that all the information given in the report is in line with the stipulated requirements of both the target audience and the required outcomes of the report.
 </a:t>
             </a:r>
-            <a:endParaRPr lang="en-US" sz="1450" dirty="0"/>
+            <a:endParaRPr lang="en-US" sz="1600" dirty="0"/>
           </a:p>
           <a:p>
             <a:pPr indent="0" marL="0">
@@ -12497,7 +12497,7 @@
               <a:buNone/>
             </a:pPr>
             <a:r>
-              <a:rPr lang="en-US" sz="1450" dirty="0">
+              <a:rPr lang="en-US" sz="1600" dirty="0">
                 <a:solidFill>
                   <a:srgbClr val="002050"/>
                 </a:solidFill>
@@ -12508,7 +12508,7 @@
               <a:t>The person who wrote the report will get another person to read through it — with the required outlines and requirements at hand — and critique it. This gives a second opinion, ensures all required information is present, and checks the report for bias toward the readers.
 </a:t>
             </a:r>
-            <a:endParaRPr lang="en-US" sz="1450" dirty="0"/>
+            <a:endParaRPr lang="en-US" sz="1600" dirty="0"/>
           </a:p>
           <a:p>
             <a:pPr indent="0" marL="0">
@@ -12521,7 +12521,7 @@
               <a:buNone/>
             </a:pPr>
             <a:r>
-              <a:rPr lang="en-US" sz="1450" dirty="0">
+              <a:rPr lang="en-US" sz="1600" dirty="0">
                 <a:solidFill>
                   <a:srgbClr val="002050"/>
                 </a:solidFill>
@@ -12532,7 +12532,7 @@
               <a:t>In many cases, once critiqued and sent for proofing, the report is handed to the head of the department for approval at least a week in advance of the expected delivery date, allowing time to give feedback on add-ons and irrelevant information.
 </a:t>
             </a:r>
-            <a:endParaRPr lang="en-US" sz="1450" dirty="0"/>
+            <a:endParaRPr lang="en-US" sz="1600" dirty="0"/>
           </a:p>
           <a:p>
             <a:pPr indent="0" marL="0">
@@ -12545,7 +12545,7 @@
               <a:buNone/>
             </a:pPr>
             <a:r>
-              <a:rPr lang="en-US" sz="1450" dirty="0">
+              <a:rPr lang="en-US" sz="1600" dirty="0">
                 <a:solidFill>
                   <a:srgbClr val="002050"/>
                 </a:solidFill>
@@ -12555,7 +12555,7 @@
               </a:rPr>
               <a:t>Throughout, organisational procedures must be strictly followed and adhered to, so that set protocols are followed for gathering and distributing the information — ensuring the report is true to its requirements and contains sufficient, but not too much, information.</a:t>
             </a:r>
-            <a:endParaRPr lang="en-US" sz="1450" dirty="0"/>
+            <a:endParaRPr lang="en-US" sz="1600" dirty="0"/>
           </a:p>
         </p:txBody>
       </p:sp>
@@ -12697,8 +12697,8 @@
         </p:nvSpPr>
         <p:spPr>
           <a:xfrm>
-            <a:off x="502920" y="274320"/>
-            <a:ext cx="11183112" cy="329184"/>
+            <a:off x="502920" y="256032"/>
+            <a:ext cx="11183112" cy="347472"/>
           </a:xfrm>
           <a:prstGeom prst="rect">
             <a:avLst/>
@@ -12714,7 +12714,7 @@
               <a:buNone/>
             </a:pPr>
             <a:r>
-              <a:rPr lang="en-US" sz="1300" b="1" spc="200" kern="0" dirty="0">
+              <a:rPr lang="en-US" sz="1400" b="1" spc="200" kern="0" dirty="0">
                 <a:solidFill>
                   <a:srgbClr val="0F6CBD"/>
                 </a:solidFill>
@@ -12724,7 +12724,7 @@
               </a:rPr>
               <a:t>QUESTION SESSION 1</a:t>
             </a:r>
-            <a:endParaRPr lang="en-US" sz="1300" dirty="0"/>
+            <a:endParaRPr lang="en-US" sz="1400" dirty="0"/>
           </a:p>
         </p:txBody>
       </p:sp>
@@ -12736,8 +12736,8 @@
         </p:nvSpPr>
         <p:spPr>
           <a:xfrm>
-            <a:off x="502920" y="603504"/>
-            <a:ext cx="11183112" cy="749808"/>
+            <a:off x="502920" y="585216"/>
+            <a:ext cx="11183112" cy="786384"/>
           </a:xfrm>
           <a:prstGeom prst="rect">
             <a:avLst/>
@@ -12753,7 +12753,7 @@
               <a:buNone/>
             </a:pPr>
             <a:r>
-              <a:rPr lang="en-US" sz="3100" b="1" dirty="0">
+              <a:rPr lang="en-US" sz="3400" b="1" dirty="0">
                 <a:solidFill>
                   <a:srgbClr val="002050"/>
                 </a:solidFill>
@@ -12763,7 +12763,7 @@
               </a:rPr>
               <a:t>Activity — Apply Your Knowledge</a:t>
             </a:r>
-            <a:endParaRPr lang="en-US" sz="3100" dirty="0"/>
+            <a:endParaRPr lang="en-US" sz="3400" dirty="0"/>
           </a:p>
         </p:txBody>
       </p:sp>
@@ -12812,7 +12812,7 @@
               <a:buNone/>
             </a:pPr>
             <a:r>
-              <a:rPr lang="en-US" sz="1700" b="1" dirty="0">
+              <a:rPr lang="en-US" sz="1800" b="1" dirty="0">
                 <a:solidFill>
                   <a:srgbClr val="FFFFFF"/>
                 </a:solidFill>
@@ -12822,7 +12822,7 @@
               </a:rPr>
               <a:t>1</a:t>
             </a:r>
-            <a:endParaRPr lang="en-US" sz="1700" dirty="0"/>
+            <a:endParaRPr lang="en-US" sz="1800" dirty="0"/>
           </a:p>
         </p:txBody>
       </p:sp>
@@ -12851,7 +12851,7 @@
               <a:buNone/>
             </a:pPr>
             <a:r>
-              <a:rPr lang="en-US" sz="1550" dirty="0">
+              <a:rPr lang="en-US" sz="1750" dirty="0">
                 <a:solidFill>
                   <a:srgbClr val="002050"/>
                 </a:solidFill>
@@ -12861,7 +12861,7 @@
               </a:rPr>
               <a:t>Give examples of different types of reports that are produced in organisations</a:t>
             </a:r>
-            <a:endParaRPr lang="en-US" sz="1550" dirty="0"/>
+            <a:endParaRPr lang="en-US" sz="1750" dirty="0"/>
           </a:p>
         </p:txBody>
       </p:sp>
@@ -12910,7 +12910,7 @@
               <a:buNone/>
             </a:pPr>
             <a:r>
-              <a:rPr lang="en-US" sz="1700" b="1" dirty="0">
+              <a:rPr lang="en-US" sz="1800" b="1" dirty="0">
                 <a:solidFill>
                   <a:srgbClr val="FFFFFF"/>
                 </a:solidFill>
@@ -12920,7 +12920,7 @@
               </a:rPr>
               <a:t>2</a:t>
             </a:r>
-            <a:endParaRPr lang="en-US" sz="1700" dirty="0"/>
+            <a:endParaRPr lang="en-US" sz="1800" dirty="0"/>
           </a:p>
         </p:txBody>
       </p:sp>
@@ -12949,7 +12949,7 @@
               <a:buNone/>
             </a:pPr>
             <a:r>
-              <a:rPr lang="en-US" sz="1550" dirty="0">
+              <a:rPr lang="en-US" sz="1750" dirty="0">
                 <a:solidFill>
                   <a:srgbClr val="002050"/>
                 </a:solidFill>
@@ -12959,7 +12959,7 @@
               </a:rPr>
               <a:t>Explain the information that will be relayed in each of the reports you have mentioned above</a:t>
             </a:r>
-            <a:endParaRPr lang="en-US" sz="1550" dirty="0"/>
+            <a:endParaRPr lang="en-US" sz="1750" dirty="0"/>
           </a:p>
         </p:txBody>
       </p:sp>
@@ -13008,7 +13008,7 @@
               <a:buNone/>
             </a:pPr>
             <a:r>
-              <a:rPr lang="en-US" sz="1700" b="1" dirty="0">
+              <a:rPr lang="en-US" sz="1800" b="1" dirty="0">
                 <a:solidFill>
                   <a:srgbClr val="FFFFFF"/>
                 </a:solidFill>
@@ -13018,7 +13018,7 @@
               </a:rPr>
               <a:t>3</a:t>
             </a:r>
-            <a:endParaRPr lang="en-US" sz="1700" dirty="0"/>
+            <a:endParaRPr lang="en-US" sz="1800" dirty="0"/>
           </a:p>
         </p:txBody>
       </p:sp>
@@ -13047,7 +13047,7 @@
               <a:buNone/>
             </a:pPr>
             <a:r>
-              <a:rPr lang="en-US" sz="1550" dirty="0">
+              <a:rPr lang="en-US" sz="1750" dirty="0">
                 <a:solidFill>
                   <a:srgbClr val="002050"/>
                 </a:solidFill>
@@ -13057,7 +13057,7 @@
               </a:rPr>
               <a:t>Explain your organisational procedures for obtaining and distributing sensitive company information</a:t>
             </a:r>
-            <a:endParaRPr lang="en-US" sz="1550" dirty="0"/>
+            <a:endParaRPr lang="en-US" sz="1750" dirty="0"/>
           </a:p>
         </p:txBody>
       </p:sp>
@@ -13106,7 +13106,7 @@
               <a:buNone/>
             </a:pPr>
             <a:r>
-              <a:rPr lang="en-US" sz="1700" b="1" dirty="0">
+              <a:rPr lang="en-US" sz="1800" b="1" dirty="0">
                 <a:solidFill>
                   <a:srgbClr val="FFFFFF"/>
                 </a:solidFill>
@@ -13116,7 +13116,7 @@
               </a:rPr>
               <a:t>4</a:t>
             </a:r>
-            <a:endParaRPr lang="en-US" sz="1700" dirty="0"/>
+            <a:endParaRPr lang="en-US" sz="1800" dirty="0"/>
           </a:p>
         </p:txBody>
       </p:sp>
@@ -13145,7 +13145,7 @@
               <a:buNone/>
             </a:pPr>
             <a:r>
-              <a:rPr lang="en-US" sz="1550" dirty="0">
+              <a:rPr lang="en-US" sz="1750" dirty="0">
                 <a:solidFill>
                   <a:srgbClr val="002050"/>
                 </a:solidFill>
@@ -13155,7 +13155,7 @@
               </a:rPr>
               <a:t>Explain your organisational procedures for obtaining sensitive company information</a:t>
             </a:r>
-            <a:endParaRPr lang="en-US" sz="1550" dirty="0"/>
+            <a:endParaRPr lang="en-US" sz="1750" dirty="0"/>
           </a:p>
         </p:txBody>
       </p:sp>
@@ -13204,7 +13204,7 @@
               <a:buNone/>
             </a:pPr>
             <a:r>
-              <a:rPr lang="en-US" sz="1700" b="1" dirty="0">
+              <a:rPr lang="en-US" sz="1800" b="1" dirty="0">
                 <a:solidFill>
                   <a:srgbClr val="FFFFFF"/>
                 </a:solidFill>
@@ -13214,7 +13214,7 @@
               </a:rPr>
               <a:t>5</a:t>
             </a:r>
-            <a:endParaRPr lang="en-US" sz="1700" dirty="0"/>
+            <a:endParaRPr lang="en-US" sz="1800" dirty="0"/>
           </a:p>
         </p:txBody>
       </p:sp>
@@ -13243,7 +13243,7 @@
               <a:buNone/>
             </a:pPr>
             <a:r>
-              <a:rPr lang="en-US" sz="1550" dirty="0">
+              <a:rPr lang="en-US" sz="1750" dirty="0">
                 <a:solidFill>
                   <a:srgbClr val="002050"/>
                 </a:solidFill>
@@ -13253,7 +13253,7 @@
               </a:rPr>
               <a:t>Identify and explain the steps that are used for compiling reports</a:t>
             </a:r>
-            <a:endParaRPr lang="en-US" sz="1550" dirty="0"/>
+            <a:endParaRPr lang="en-US" sz="1750" dirty="0"/>
           </a:p>
         </p:txBody>
       </p:sp>
@@ -13302,7 +13302,7 @@
               <a:buNone/>
             </a:pPr>
             <a:r>
-              <a:rPr lang="en-US" sz="1700" b="1" dirty="0">
+              <a:rPr lang="en-US" sz="1800" b="1" dirty="0">
                 <a:solidFill>
                   <a:srgbClr val="FFFFFF"/>
                 </a:solidFill>
@@ -13312,7 +13312,7 @@
               </a:rPr>
               <a:t>6</a:t>
             </a:r>
-            <a:endParaRPr lang="en-US" sz="1700" dirty="0"/>
+            <a:endParaRPr lang="en-US" sz="1800" dirty="0"/>
           </a:p>
         </p:txBody>
       </p:sp>
@@ -13341,7 +13341,7 @@
               <a:buNone/>
             </a:pPr>
             <a:r>
-              <a:rPr lang="en-US" sz="1550" dirty="0">
+              <a:rPr lang="en-US" sz="1750" dirty="0">
                 <a:solidFill>
                   <a:srgbClr val="002050"/>
                 </a:solidFill>
@@ -13351,7 +13351,7 @@
               </a:rPr>
               <a:t>Explain how to ensure that the reported information is in accordance with the requirements of the report</a:t>
             </a:r>
-            <a:endParaRPr lang="en-US" sz="1550" dirty="0"/>
+            <a:endParaRPr lang="en-US" sz="1750" dirty="0"/>
           </a:p>
         </p:txBody>
       </p:sp>
@@ -13493,8 +13493,8 @@
         </p:nvSpPr>
         <p:spPr>
           <a:xfrm>
-            <a:off x="502920" y="274320"/>
-            <a:ext cx="11183112" cy="329184"/>
+            <a:off x="502920" y="256032"/>
+            <a:ext cx="11183112" cy="347472"/>
           </a:xfrm>
           <a:prstGeom prst="rect">
             <a:avLst/>
@@ -13510,7 +13510,7 @@
               <a:buNone/>
             </a:pPr>
             <a:r>
-              <a:rPr lang="en-US" sz="1300" b="1" spc="200" kern="0" dirty="0">
+              <a:rPr lang="en-US" sz="1400" b="1" spc="200" kern="0" dirty="0">
                 <a:solidFill>
                   <a:srgbClr val="0F6CBD"/>
                 </a:solidFill>
@@ -13520,7 +13520,7 @@
               </a:rPr>
               <a:t>SELF-ASSESSMENT</a:t>
             </a:r>
-            <a:endParaRPr lang="en-US" sz="1300" dirty="0"/>
+            <a:endParaRPr lang="en-US" sz="1400" dirty="0"/>
           </a:p>
         </p:txBody>
       </p:sp>
@@ -13532,8 +13532,8 @@
         </p:nvSpPr>
         <p:spPr>
           <a:xfrm>
-            <a:off x="502920" y="603504"/>
-            <a:ext cx="11183112" cy="749808"/>
+            <a:off x="502920" y="585216"/>
+            <a:ext cx="11183112" cy="786384"/>
           </a:xfrm>
           <a:prstGeom prst="rect">
             <a:avLst/>
@@ -13549,7 +13549,7 @@
               <a:buNone/>
             </a:pPr>
             <a:r>
-              <a:rPr lang="en-US" sz="3100" b="1" dirty="0">
+              <a:rPr lang="en-US" sz="3400" b="1" dirty="0">
                 <a:solidFill>
                   <a:srgbClr val="002050"/>
                 </a:solidFill>
@@ -13559,7 +13559,7 @@
               </a:rPr>
               <a:t>Self-Assessment — Be Honest With Yourself</a:t>
             </a:r>
-            <a:endParaRPr lang="en-US" sz="3100" dirty="0"/>
+            <a:endParaRPr lang="en-US" sz="3400" dirty="0"/>
           </a:p>
         </p:txBody>
       </p:sp>
@@ -13588,7 +13588,7 @@
               <a:buNone/>
             </a:pPr>
             <a:r>
-              <a:rPr lang="en-US" sz="1450" dirty="0">
+              <a:rPr lang="en-US" sz="1600" dirty="0">
                 <a:solidFill>
                   <a:srgbClr val="6B7280"/>
                 </a:solidFill>
@@ -13598,7 +13598,7 @@
               </a:rPr>
               <a:t>Tick the box with a ✓ or an ✗ to indicate your response.</a:t>
             </a:r>
-            <a:endParaRPr lang="en-US" sz="1450" dirty="0"/>
+            <a:endParaRPr lang="en-US" sz="1600" dirty="0"/>
           </a:p>
         </p:txBody>
       </p:sp>
@@ -13654,7 +13654,7 @@
               <a:buNone/>
             </a:pPr>
             <a:r>
-              <a:rPr lang="en-US" sz="1500" dirty="0">
+              <a:rPr lang="en-US" sz="1650" dirty="0">
                 <a:solidFill>
                   <a:srgbClr val="002050"/>
                 </a:solidFill>
@@ -13664,7 +13664,7 @@
               </a:rPr>
               <a:t>I am able to identify and explain different types of reports used in organisations</a:t>
             </a:r>
-            <a:endParaRPr lang="en-US" sz="1500" dirty="0"/>
+            <a:endParaRPr lang="en-US" sz="1650" dirty="0"/>
           </a:p>
         </p:txBody>
       </p:sp>
@@ -13720,7 +13720,7 @@
               <a:buNone/>
             </a:pPr>
             <a:r>
-              <a:rPr lang="en-US" sz="1500" dirty="0">
+              <a:rPr lang="en-US" sz="1650" dirty="0">
                 <a:solidFill>
                   <a:srgbClr val="002050"/>
                 </a:solidFill>
@@ -13730,7 +13730,7 @@
               </a:rPr>
               <a:t>I am able to explain the use of the different types of reports</a:t>
             </a:r>
-            <a:endParaRPr lang="en-US" sz="1500" dirty="0"/>
+            <a:endParaRPr lang="en-US" sz="1650" dirty="0"/>
           </a:p>
         </p:txBody>
       </p:sp>
@@ -13786,7 +13786,7 @@
               <a:buNone/>
             </a:pPr>
             <a:r>
-              <a:rPr lang="en-US" sz="1500" dirty="0">
+              <a:rPr lang="en-US" sz="1650" dirty="0">
                 <a:solidFill>
                   <a:srgbClr val="002050"/>
                 </a:solidFill>
@@ -13796,7 +13796,7 @@
               </a:rPr>
               <a:t>I am able to identify and explain the reasons for handling confidential information confidentially</a:t>
             </a:r>
-            <a:endParaRPr lang="en-US" sz="1500" dirty="0"/>
+            <a:endParaRPr lang="en-US" sz="1650" dirty="0"/>
           </a:p>
         </p:txBody>
       </p:sp>
@@ -13852,7 +13852,7 @@
               <a:buNone/>
             </a:pPr>
             <a:r>
-              <a:rPr lang="en-US" sz="1500" dirty="0">
+              <a:rPr lang="en-US" sz="1650" dirty="0">
                 <a:solidFill>
                   <a:srgbClr val="002050"/>
                 </a:solidFill>
@@ -13862,7 +13862,7 @@
               </a:rPr>
               <a:t>I am able to explain a range of techniques for compiling reports</a:t>
             </a:r>
-            <a:endParaRPr lang="en-US" sz="1500" dirty="0"/>
+            <a:endParaRPr lang="en-US" sz="1650" dirty="0"/>
           </a:p>
         </p:txBody>
       </p:sp>
@@ -13918,7 +13918,7 @@
               <a:buNone/>
             </a:pPr>
             <a:r>
-              <a:rPr lang="en-US" sz="1500" dirty="0">
+              <a:rPr lang="en-US" sz="1650" dirty="0">
                 <a:solidFill>
                   <a:srgbClr val="002050"/>
                 </a:solidFill>
@@ -13928,7 +13928,7 @@
               </a:rPr>
               <a:t>I am able to explain how the reported information is checked for appropriateness and then distributed according to the intended audience of the report</a:t>
             </a:r>
-            <a:endParaRPr lang="en-US" sz="1500" dirty="0"/>
+            <a:endParaRPr lang="en-US" sz="1650" dirty="0"/>
           </a:p>
         </p:txBody>
       </p:sp>
@@ -14024,7 +14024,7 @@
               <a:buNone/>
             </a:pPr>
             <a:r>
-              <a:rPr lang="en-US" sz="1450" dirty="0">
+              <a:rPr lang="en-US" sz="1600" dirty="0">
                 <a:solidFill>
                   <a:srgbClr val="002050"/>
                 </a:solidFill>
@@ -14034,7 +14034,7 @@
               </a:rPr>
               <a:t>Think about any point you could not tick. Write it down as a goal, decide on a plan of action to achieve it, and review your goals regularly.</a:t>
             </a:r>
-            <a:endParaRPr lang="en-US" sz="1450" dirty="0"/>
+            <a:endParaRPr lang="en-US" sz="1600" dirty="0"/>
           </a:p>
         </p:txBody>
       </p:sp>
@@ -14176,8 +14176,8 @@
         </p:nvSpPr>
         <p:spPr>
           <a:xfrm>
-            <a:off x="502920" y="274320"/>
-            <a:ext cx="11183112" cy="329184"/>
+            <a:off x="502920" y="256032"/>
+            <a:ext cx="11183112" cy="347472"/>
           </a:xfrm>
           <a:prstGeom prst="rect">
             <a:avLst/>
@@ -14193,7 +14193,7 @@
               <a:buNone/>
             </a:pPr>
             <a:r>
-              <a:rPr lang="en-US" sz="1300" b="1" spc="200" kern="0" dirty="0">
+              <a:rPr lang="en-US" sz="1400" b="1" spc="200" kern="0" dirty="0">
                 <a:solidFill>
                   <a:srgbClr val="0F6CBD"/>
                 </a:solidFill>
@@ -14203,7 +14203,7 @@
               </a:rPr>
               <a:t>SPECIFIC OUTCOMES AND RELATED ASSESSMENT CRITERIA</a:t>
             </a:r>
-            <a:endParaRPr lang="en-US" sz="1300" dirty="0"/>
+            <a:endParaRPr lang="en-US" sz="1400" dirty="0"/>
           </a:p>
         </p:txBody>
       </p:sp>
@@ -14215,8 +14215,8 @@
         </p:nvSpPr>
         <p:spPr>
           <a:xfrm>
-            <a:off x="502920" y="603504"/>
-            <a:ext cx="11183112" cy="749808"/>
+            <a:off x="502920" y="585216"/>
+            <a:ext cx="11183112" cy="786384"/>
           </a:xfrm>
           <a:prstGeom prst="rect">
             <a:avLst/>
@@ -14232,7 +14232,7 @@
               <a:buNone/>
             </a:pPr>
             <a:r>
-              <a:rPr lang="en-US" sz="3100" b="1" dirty="0">
+              <a:rPr lang="en-US" sz="3400" b="1" dirty="0">
                 <a:solidFill>
                   <a:srgbClr val="002050"/>
                 </a:solidFill>
@@ -14242,7 +14242,7 @@
               </a:rPr>
               <a:t>Alignment Index — Specific Outcomes</a:t>
             </a:r>
-            <a:endParaRPr lang="en-US" sz="3100" dirty="0"/>
+            <a:endParaRPr lang="en-US" sz="3400" dirty="0"/>
           </a:p>
         </p:txBody>
       </p:sp>
@@ -14305,7 +14305,7 @@
               <a:buNone/>
             </a:pPr>
             <a:r>
-              <a:rPr lang="en-US" sz="1600" b="1" dirty="0">
+              <a:rPr lang="en-US" sz="1800" b="1" dirty="0">
                 <a:solidFill>
                   <a:srgbClr val="0F6CBD"/>
                 </a:solidFill>
@@ -14319,7 +14319,7 @@
               <a:buNone/>
             </a:pPr>
             <a:r>
-              <a:rPr lang="en-US" sz="1600" dirty="0">
+              <a:rPr lang="en-US" sz="1800" dirty="0">
                 <a:solidFill>
                   <a:srgbClr val="002050"/>
                 </a:solidFill>
@@ -14329,7 +14329,7 @@
               </a:rPr>
               <a:t>The demonstrated ability to make decisions and consider options when:</a:t>
             </a:r>
-            <a:endParaRPr lang="en-US" sz="1600" dirty="0"/>
+            <a:endParaRPr lang="en-US" sz="1800" dirty="0"/>
           </a:p>
         </p:txBody>
       </p:sp>
@@ -14365,7 +14365,7 @@
               <a:buChar char="•"/>
             </a:pPr>
             <a:r>
-              <a:rPr lang="en-US" sz="1550" dirty="0">
+              <a:rPr lang="en-US" sz="1700" dirty="0">
                 <a:solidFill>
                   <a:srgbClr val="002050"/>
                 </a:solidFill>
@@ -14375,7 +14375,7 @@
               </a:rPr>
               <a:t>Relating the purpose and content of a range of reports to the information needs of business</a:t>
             </a:r>
-            <a:endParaRPr lang="en-US" sz="1550" dirty="0"/>
+            <a:endParaRPr lang="en-US" sz="1700" dirty="0"/>
           </a:p>
           <a:p>
             <a:pPr marL="228600" indent="-228600">
@@ -14389,7 +14389,7 @@
               <a:buChar char="•"/>
             </a:pPr>
             <a:r>
-              <a:rPr lang="en-US" sz="1550" dirty="0">
+              <a:rPr lang="en-US" sz="1700" dirty="0">
                 <a:solidFill>
                   <a:srgbClr val="002050"/>
                 </a:solidFill>
@@ -14399,7 +14399,7 @@
               </a:rPr>
               <a:t>Recognising appropriate information resources and organisational procedures for obtaining and distributing confidential information</a:t>
             </a:r>
-            <a:endParaRPr lang="en-US" sz="1550" dirty="0"/>
+            <a:endParaRPr lang="en-US" sz="1700" dirty="0"/>
           </a:p>
           <a:p>
             <a:pPr marL="228600" indent="-228600">
@@ -14413,7 +14413,7 @@
               <a:buChar char="•"/>
             </a:pPr>
             <a:r>
-              <a:rPr lang="en-US" sz="1550" dirty="0">
+              <a:rPr lang="en-US" sz="1700" dirty="0">
                 <a:solidFill>
                   <a:srgbClr val="002050"/>
                 </a:solidFill>
@@ -14423,7 +14423,7 @@
               </a:rPr>
               <a:t>Applying a range of techniques for compiling reports, ensuring content and format are appropriate to information requirements and that reporting deadlines are met</a:t>
             </a:r>
-            <a:endParaRPr lang="en-US" sz="1550" dirty="0"/>
+            <a:endParaRPr lang="en-US" sz="1700" dirty="0"/>
           </a:p>
           <a:p>
             <a:pPr marL="228600" indent="-228600">
@@ -14437,7 +14437,7 @@
               <a:buChar char="•"/>
             </a:pPr>
             <a:r>
-              <a:rPr lang="en-US" sz="1550" dirty="0">
+              <a:rPr lang="en-US" sz="1700" dirty="0">
                 <a:solidFill>
                   <a:srgbClr val="002050"/>
                 </a:solidFill>
@@ -14447,7 +14447,7 @@
               </a:rPr>
               <a:t>Liaising with relevant parties and verifying reported information is in accordance with requirements, compiling and distributing additional commentary/information where required</a:t>
             </a:r>
-            <a:endParaRPr lang="en-US" sz="1550" dirty="0"/>
+            <a:endParaRPr lang="en-US" sz="1700" dirty="0"/>
           </a:p>
         </p:txBody>
       </p:sp>
@@ -14459,8 +14459,8 @@
         </p:nvSpPr>
         <p:spPr>
           <a:xfrm>
-            <a:off x="502920" y="5715000"/>
-            <a:ext cx="2011680" cy="475488"/>
+            <a:off x="502920" y="5806440"/>
+            <a:ext cx="2286000" cy="512064"/>
           </a:xfrm>
           <a:prstGeom prst="roundRect">
             <a:avLst>
@@ -14481,8 +14481,8 @@
         </p:nvSpPr>
         <p:spPr>
           <a:xfrm>
-            <a:off x="502920" y="5715000"/>
-            <a:ext cx="2011680" cy="475488"/>
+            <a:off x="502920" y="5806440"/>
+            <a:ext cx="2286000" cy="512064"/>
           </a:xfrm>
           <a:prstGeom prst="rect">
             <a:avLst/>
@@ -14498,7 +14498,7 @@
               <a:buNone/>
             </a:pPr>
             <a:r>
-              <a:rPr lang="en-US" sz="1250" b="1" dirty="0">
+              <a:rPr lang="en-US" sz="1400" b="1" dirty="0">
                 <a:solidFill>
                   <a:srgbClr val="FFFFFF"/>
                 </a:solidFill>
@@ -14508,7 +14508,7 @@
               </a:rPr>
               <a:t>AC 1 — as for SO 1</a:t>
             </a:r>
-            <a:endParaRPr lang="en-US" sz="1250" dirty="0"/>
+            <a:endParaRPr lang="en-US" sz="1400" dirty="0"/>
           </a:p>
         </p:txBody>
       </p:sp>
@@ -14650,8 +14650,8 @@
         </p:nvSpPr>
         <p:spPr>
           <a:xfrm>
-            <a:off x="502920" y="274320"/>
-            <a:ext cx="11183112" cy="329184"/>
+            <a:off x="502920" y="256032"/>
+            <a:ext cx="11183112" cy="347472"/>
           </a:xfrm>
           <a:prstGeom prst="rect">
             <a:avLst/>
@@ -14667,7 +14667,7 @@
               <a:buNone/>
             </a:pPr>
             <a:r>
-              <a:rPr lang="en-US" sz="1300" b="1" spc="200" kern="0" dirty="0">
+              <a:rPr lang="en-US" sz="1400" b="1" spc="200" kern="0" dirty="0">
                 <a:solidFill>
                   <a:srgbClr val="0F6CBD"/>
                 </a:solidFill>
@@ -14677,7 +14677,7 @@
               </a:rPr>
               <a:t>CRITICAL CROSS-FIELD OUTCOMES</a:t>
             </a:r>
-            <a:endParaRPr lang="en-US" sz="1300" dirty="0"/>
+            <a:endParaRPr lang="en-US" sz="1400" dirty="0"/>
           </a:p>
         </p:txBody>
       </p:sp>
@@ -14689,8 +14689,8 @@
         </p:nvSpPr>
         <p:spPr>
           <a:xfrm>
-            <a:off x="502920" y="603504"/>
-            <a:ext cx="11183112" cy="749808"/>
+            <a:off x="502920" y="585216"/>
+            <a:ext cx="11183112" cy="786384"/>
           </a:xfrm>
           <a:prstGeom prst="rect">
             <a:avLst/>
@@ -14706,7 +14706,7 @@
               <a:buNone/>
             </a:pPr>
             <a:r>
-              <a:rPr lang="en-US" sz="3100" b="1" dirty="0">
+              <a:rPr lang="en-US" sz="3400" b="1" dirty="0">
                 <a:solidFill>
                   <a:srgbClr val="002050"/>
                 </a:solidFill>
@@ -14716,7 +14716,7 @@
               </a:rPr>
               <a:t>Critical Cross-Field Outcomes</a:t>
             </a:r>
-            <a:endParaRPr lang="en-US" sz="3100" dirty="0"/>
+            <a:endParaRPr lang="en-US" sz="3400" dirty="0"/>
           </a:p>
         </p:txBody>
       </p:sp>
@@ -14802,7 +14802,7 @@
               <a:buNone/>
             </a:pPr>
             <a:r>
-              <a:rPr lang="en-US" sz="1800" b="1" dirty="0">
+              <a:rPr lang="en-US" sz="2000" b="1" dirty="0">
                 <a:solidFill>
                   <a:srgbClr val="002050"/>
                 </a:solidFill>
@@ -14820,7 +14820,7 @@
               <a:buNone/>
             </a:pPr>
             <a:r>
-              <a:rPr lang="en-US" sz="1450" dirty="0">
+              <a:rPr lang="en-US" sz="1600" dirty="0">
                 <a:solidFill>
                   <a:srgbClr val="002050"/>
                 </a:solidFill>
@@ -14830,7 +14830,7 @@
               </a:rPr>
               <a:t>Demonstrate an understanding of the world as a set of related systems where follow-up actions are vital to ensuring that confidential information is received and verified by authorised recipients.</a:t>
             </a:r>
-            <a:endParaRPr lang="en-US" sz="1800" dirty="0"/>
+            <a:endParaRPr lang="en-US" sz="2000" dirty="0"/>
           </a:p>
         </p:txBody>
       </p:sp>
@@ -14916,7 +14916,7 @@
               <a:buNone/>
             </a:pPr>
             <a:r>
-              <a:rPr lang="en-US" sz="1800" b="1" dirty="0">
+              <a:rPr lang="en-US" sz="2000" b="1" dirty="0">
                 <a:solidFill>
                   <a:srgbClr val="002050"/>
                 </a:solidFill>
@@ -14934,7 +14934,7 @@
               <a:buNone/>
             </a:pPr>
             <a:r>
-              <a:rPr lang="en-US" sz="1450" dirty="0">
+              <a:rPr lang="en-US" sz="1600" dirty="0">
                 <a:solidFill>
                   <a:srgbClr val="002050"/>
                 </a:solidFill>
@@ -14944,7 +14944,7 @@
               </a:rPr>
               <a:t>Organise oneself and one's activities when compiling reports so that sufficient time is set aside to check comprehensiveness and accuracy of information reported.</a:t>
             </a:r>
-            <a:endParaRPr lang="en-US" sz="1800" dirty="0"/>
+            <a:endParaRPr lang="en-US" sz="2000" dirty="0"/>
           </a:p>
         </p:txBody>
       </p:sp>
@@ -15030,7 +15030,7 @@
               <a:buNone/>
             </a:pPr>
             <a:r>
-              <a:rPr lang="en-US" sz="1800" b="1" dirty="0">
+              <a:rPr lang="en-US" sz="2000" b="1" dirty="0">
                 <a:solidFill>
                   <a:srgbClr val="002050"/>
                 </a:solidFill>
@@ -15048,7 +15048,7 @@
               <a:buNone/>
             </a:pPr>
             <a:r>
-              <a:rPr lang="en-US" sz="1450" dirty="0">
+              <a:rPr lang="en-US" sz="1600" dirty="0">
                 <a:solidFill>
                   <a:srgbClr val="002050"/>
                 </a:solidFill>
@@ -15058,7 +15058,7 @@
               </a:rPr>
               <a:t>Collect, organise, analyse and critically evaluate information when compiling reports so that information reflected is appropriate to business needs.</a:t>
             </a:r>
-            <a:endParaRPr lang="en-US" sz="1800" dirty="0"/>
+            <a:endParaRPr lang="en-US" sz="2000" dirty="0"/>
           </a:p>
         </p:txBody>
       </p:sp>
@@ -15144,7 +15144,7 @@
               <a:buNone/>
             </a:pPr>
             <a:r>
-              <a:rPr lang="en-US" sz="1800" b="1" dirty="0">
+              <a:rPr lang="en-US" sz="2000" b="1" dirty="0">
                 <a:solidFill>
                   <a:srgbClr val="002050"/>
                 </a:solidFill>
@@ -15162,7 +15162,7 @@
               <a:buNone/>
             </a:pPr>
             <a:r>
-              <a:rPr lang="en-US" sz="1450" dirty="0">
+              <a:rPr lang="en-US" sz="1600" dirty="0">
                 <a:solidFill>
                   <a:srgbClr val="002050"/>
                 </a:solidFill>
@@ -15172,7 +15172,7 @@
               </a:rPr>
               <a:t>Communicate effectively when compiling written reports by applying a style and format that facilitates clear interpretation of facts presented on the part of the recipient.</a:t>
             </a:r>
-            <a:endParaRPr lang="en-US" sz="1800" dirty="0"/>
+            <a:endParaRPr lang="en-US" sz="2000" dirty="0"/>
           </a:p>
         </p:txBody>
       </p:sp>
@@ -15314,8 +15314,8 @@
         </p:nvSpPr>
         <p:spPr>
           <a:xfrm>
-            <a:off x="502920" y="274320"/>
-            <a:ext cx="11183112" cy="329184"/>
+            <a:off x="502920" y="256032"/>
+            <a:ext cx="11183112" cy="347472"/>
           </a:xfrm>
           <a:prstGeom prst="rect">
             <a:avLst/>
@@ -15331,7 +15331,7 @@
               <a:buNone/>
             </a:pPr>
             <a:r>
-              <a:rPr lang="en-US" sz="1300" b="1" spc="200" kern="0" dirty="0">
+              <a:rPr lang="en-US" sz="1400" b="1" spc="200" kern="0" dirty="0">
                 <a:solidFill>
                   <a:srgbClr val="0F6CBD"/>
                 </a:solidFill>
@@ -15341,7 +15341,7 @@
               </a:rPr>
               <a:t>PURPOSE &amp; CONTENT OF REPORTS</a:t>
             </a:r>
-            <a:endParaRPr lang="en-US" sz="1300" dirty="0"/>
+            <a:endParaRPr lang="en-US" sz="1400" dirty="0"/>
           </a:p>
         </p:txBody>
       </p:sp>
@@ -15353,8 +15353,8 @@
         </p:nvSpPr>
         <p:spPr>
           <a:xfrm>
-            <a:off x="502920" y="603504"/>
-            <a:ext cx="11183112" cy="749808"/>
+            <a:off x="502920" y="585216"/>
+            <a:ext cx="11183112" cy="786384"/>
           </a:xfrm>
           <a:prstGeom prst="rect">
             <a:avLst/>
@@ -15370,7 +15370,7 @@
               <a:buNone/>
             </a:pPr>
             <a:r>
-              <a:rPr lang="en-US" sz="3100" b="1" dirty="0">
+              <a:rPr lang="en-US" sz="3400" b="1" dirty="0">
                 <a:solidFill>
                   <a:srgbClr val="002050"/>
                 </a:solidFill>
@@ -15380,7 +15380,7 @@
               </a:rPr>
               <a:t>Introduction</a:t>
             </a:r>
-            <a:endParaRPr lang="en-US" sz="3100" dirty="0"/>
+            <a:endParaRPr lang="en-US" sz="3400" dirty="0"/>
           </a:p>
         </p:txBody>
       </p:sp>
@@ -15415,7 +15415,7 @@
               <a:buNone/>
             </a:pPr>
             <a:r>
-              <a:rPr lang="en-US" sz="1550" dirty="0">
+              <a:rPr lang="en-US" sz="1700" dirty="0">
                 <a:solidFill>
                   <a:srgbClr val="002050"/>
                 </a:solidFill>
@@ -15426,7 +15426,7 @@
               <a:t>Because we are dealing with business communication, this section is based on business communication, but the remainder of the types of reports do not differ much from this type of report. By practising how to write an internal report on a business related matter, we will prepare you to learn the basics of report writing so that you may develop to writing more advanced and specific reports as you move up in your career.
 </a:t>
             </a:r>
-            <a:endParaRPr lang="en-US" sz="1550" dirty="0"/>
+            <a:endParaRPr lang="en-US" sz="1700" dirty="0"/>
           </a:p>
           <a:p>
             <a:pPr indent="0" marL="0">
@@ -15439,7 +15439,7 @@
               <a:buNone/>
             </a:pPr>
             <a:r>
-              <a:rPr lang="en-US" sz="1550" dirty="0">
+              <a:rPr lang="en-US" sz="1700" dirty="0">
                 <a:solidFill>
                   <a:srgbClr val="002050"/>
                 </a:solidFill>
@@ -15450,7 +15450,7 @@
               <a:t>There are a few general rules about report writing. A report should be a formal document and should be in the past tense as far as possible, as well as avoiding the use of first or second person pronouns. There should be a simple numbering system with clear headings.
 </a:t>
             </a:r>
-            <a:endParaRPr lang="en-US" sz="1550" dirty="0"/>
+            <a:endParaRPr lang="en-US" sz="1700" dirty="0"/>
           </a:p>
           <a:p>
             <a:pPr indent="0" marL="0">
@@ -15463,7 +15463,7 @@
               <a:buNone/>
             </a:pPr>
             <a:r>
-              <a:rPr lang="en-US" sz="1550" dirty="0">
+              <a:rPr lang="en-US" sz="1700" dirty="0">
                 <a:solidFill>
                   <a:srgbClr val="002050"/>
                 </a:solidFill>
@@ -15473,7 +15473,7 @@
               </a:rPr>
               <a:t>Before we start writing reports in business, we need to understand what the purpose of the report is — i.e. the outcome, or required outcome thereof — as well as the manner (style) in which the report must be written. Writing a report in a style which is not suited to its audience or readers will not be professional. Therefore we must understand what we need to put into the report and phrase it appropriately so that the readers understand the information being given to them.</a:t>
             </a:r>
-            <a:endParaRPr lang="en-US" sz="1550" dirty="0"/>
+            <a:endParaRPr lang="en-US" sz="1700" dirty="0"/>
           </a:p>
         </p:txBody>
       </p:sp>
@@ -15615,8 +15615,8 @@
         </p:nvSpPr>
         <p:spPr>
           <a:xfrm>
-            <a:off x="502920" y="274320"/>
-            <a:ext cx="11183112" cy="329184"/>
+            <a:off x="502920" y="256032"/>
+            <a:ext cx="11183112" cy="347472"/>
           </a:xfrm>
           <a:prstGeom prst="rect">
             <a:avLst/>
@@ -15632,7 +15632,7 @@
               <a:buNone/>
             </a:pPr>
             <a:r>
-              <a:rPr lang="en-US" sz="1300" b="1" spc="200" kern="0" dirty="0">
+              <a:rPr lang="en-US" sz="1400" b="1" spc="200" kern="0" dirty="0">
                 <a:solidFill>
                   <a:srgbClr val="0F6CBD"/>
                 </a:solidFill>
@@ -15642,7 +15642,7 @@
               </a:rPr>
               <a:t>HOW TO WRITE A REPORT</a:t>
             </a:r>
-            <a:endParaRPr lang="en-US" sz="1300" dirty="0"/>
+            <a:endParaRPr lang="en-US" sz="1400" dirty="0"/>
           </a:p>
         </p:txBody>
       </p:sp>
@@ -15654,8 +15654,8 @@
         </p:nvSpPr>
         <p:spPr>
           <a:xfrm>
-            <a:off x="502920" y="603504"/>
-            <a:ext cx="11183112" cy="749808"/>
+            <a:off x="502920" y="585216"/>
+            <a:ext cx="11183112" cy="786384"/>
           </a:xfrm>
           <a:prstGeom prst="rect">
             <a:avLst/>
@@ -15671,7 +15671,7 @@
               <a:buNone/>
             </a:pPr>
             <a:r>
-              <a:rPr lang="en-US" sz="3100" b="1" dirty="0">
+              <a:rPr lang="en-US" sz="3400" b="1" dirty="0">
                 <a:solidFill>
                   <a:srgbClr val="002050"/>
                 </a:solidFill>
@@ -15681,7 +15681,7 @@
               </a:rPr>
               <a:t>How to Write a Report — Style</a:t>
             </a:r>
-            <a:endParaRPr lang="en-US" sz="3100" dirty="0"/>
+            <a:endParaRPr lang="en-US" sz="3400" dirty="0"/>
           </a:p>
         </p:txBody>
       </p:sp>
@@ -15716,7 +15716,7 @@
               <a:buNone/>
             </a:pPr>
             <a:r>
-              <a:rPr lang="en-US" sz="1700" dirty="0">
+              <a:rPr lang="en-US" sz="1900" dirty="0">
                 <a:solidFill>
                   <a:srgbClr val="002050"/>
                 </a:solidFill>
@@ -15727,7 +15727,7 @@
               <a:t>To be completely successful, a report which makes recommendations must ensure that the persons for whom the report is intended:
 </a:t>
             </a:r>
-            <a:endParaRPr lang="en-US" sz="1700" dirty="0"/>
+            <a:endParaRPr lang="en-US" sz="1900" dirty="0"/>
           </a:p>
           <a:p>
             <a:pPr marL="228600" indent="-228600">
@@ -15741,7 +15741,7 @@
               <a:buChar char="•"/>
             </a:pPr>
             <a:r>
-              <a:rPr lang="en-US" sz="1700" dirty="0">
+              <a:rPr lang="en-US" sz="1900" dirty="0">
                 <a:solidFill>
                   <a:srgbClr val="002050"/>
                 </a:solidFill>
@@ -15751,7 +15751,7 @@
               </a:rPr>
               <a:t>Read it without unnecessary delay</a:t>
             </a:r>
-            <a:endParaRPr lang="en-US" sz="1700" dirty="0"/>
+            <a:endParaRPr lang="en-US" sz="1900" dirty="0"/>
           </a:p>
           <a:p>
             <a:pPr marL="228600" indent="-228600">
@@ -15765,7 +15765,7 @@
               <a:buChar char="•"/>
             </a:pPr>
             <a:r>
-              <a:rPr lang="en-US" sz="1700" dirty="0">
+              <a:rPr lang="en-US" sz="1900" dirty="0">
                 <a:solidFill>
                   <a:srgbClr val="002050"/>
                 </a:solidFill>
@@ -15775,7 +15775,7 @@
               </a:rPr>
               <a:t>Understand everything in it without undue effort</a:t>
             </a:r>
-            <a:endParaRPr lang="en-US" sz="1700" dirty="0"/>
+            <a:endParaRPr lang="en-US" sz="1900" dirty="0"/>
           </a:p>
           <a:p>
             <a:pPr marL="228600" indent="-228600">
@@ -15789,7 +15789,7 @@
               <a:buChar char="•"/>
             </a:pPr>
             <a:r>
-              <a:rPr lang="en-US" sz="1700" dirty="0">
+              <a:rPr lang="en-US" sz="1900" dirty="0">
                 <a:solidFill>
                   <a:srgbClr val="002050"/>
                 </a:solidFill>
@@ -15799,7 +15799,7 @@
               </a:rPr>
               <a:t>Accept the facts, findings, conclusions and recommendations</a:t>
             </a:r>
-            <a:endParaRPr lang="en-US" sz="1700" dirty="0"/>
+            <a:endParaRPr lang="en-US" sz="1900" dirty="0"/>
           </a:p>
           <a:p>
             <a:pPr marL="228600" indent="-228600">
@@ -15813,7 +15813,7 @@
               <a:buChar char="•"/>
             </a:pPr>
             <a:r>
-              <a:rPr lang="en-US" sz="1700" dirty="0">
+              <a:rPr lang="en-US" sz="1900" dirty="0">
                 <a:solidFill>
                   <a:srgbClr val="002050"/>
                 </a:solidFill>
@@ -15823,7 +15823,7 @@
               </a:rPr>
               <a:t>Decide to take the action recommended</a:t>
             </a:r>
-            <a:endParaRPr lang="en-US" sz="1700" dirty="0"/>
+            <a:endParaRPr lang="en-US" sz="1900" dirty="0"/>
           </a:p>
         </p:txBody>
       </p:sp>
@@ -15919,7 +15919,7 @@
               <a:buNone/>
             </a:pPr>
             <a:r>
-              <a:rPr lang="en-US" sz="1550" dirty="0">
+              <a:rPr lang="en-US" sz="1700" dirty="0">
                 <a:solidFill>
                   <a:srgbClr val="002050"/>
                 </a:solidFill>
@@ -15929,7 +15929,7 @@
               </a:rPr>
               <a:t>Achieving this demands more of you than merely presenting relevant facts accurately. It also demands that you communicate in a way that is both acceptable and intelligible to the readers.</a:t>
             </a:r>
-            <a:endParaRPr lang="en-US" sz="1550" dirty="0"/>
+            <a:endParaRPr lang="en-US" sz="1700" dirty="0"/>
           </a:p>
         </p:txBody>
       </p:sp>
@@ -16071,8 +16071,8 @@
         </p:nvSpPr>
         <p:spPr>
           <a:xfrm>
-            <a:off x="502920" y="274320"/>
-            <a:ext cx="11183112" cy="329184"/>
+            <a:off x="502920" y="256032"/>
+            <a:ext cx="11183112" cy="347472"/>
           </a:xfrm>
           <a:prstGeom prst="rect">
             <a:avLst/>
@@ -16088,7 +16088,7 @@
               <a:buNone/>
             </a:pPr>
             <a:r>
-              <a:rPr lang="en-US" sz="1300" b="1" spc="200" kern="0" dirty="0">
+              <a:rPr lang="en-US" sz="1400" b="1" spc="200" kern="0" dirty="0">
                 <a:solidFill>
                   <a:srgbClr val="0F6CBD"/>
                 </a:solidFill>
@@ -16098,7 +16098,7 @@
               </a:rPr>
               <a:t>QUALITIES OF GOOD REPORT WRITING · 1 OF 2</a:t>
             </a:r>
-            <a:endParaRPr lang="en-US" sz="1300" dirty="0"/>
+            <a:endParaRPr lang="en-US" sz="1400" dirty="0"/>
           </a:p>
         </p:txBody>
       </p:sp>
@@ -16110,8 +16110,8 @@
         </p:nvSpPr>
         <p:spPr>
           <a:xfrm>
-            <a:off x="502920" y="603504"/>
-            <a:ext cx="11183112" cy="749808"/>
+            <a:off x="502920" y="585216"/>
+            <a:ext cx="11183112" cy="786384"/>
           </a:xfrm>
           <a:prstGeom prst="rect">
             <a:avLst/>
@@ -16127,7 +16127,7 @@
               <a:buNone/>
             </a:pPr>
             <a:r>
-              <a:rPr lang="en-US" sz="3100" b="1" dirty="0">
+              <a:rPr lang="en-US" sz="3400" b="1" dirty="0">
                 <a:solidFill>
                   <a:srgbClr val="002050"/>
                 </a:solidFill>
@@ -16137,7 +16137,7 @@
               </a:rPr>
               <a:t>The Qualities of Good Report Writing</a:t>
             </a:r>
-            <a:endParaRPr lang="en-US" sz="3100" dirty="0"/>
+            <a:endParaRPr lang="en-US" sz="3400" dirty="0"/>
           </a:p>
         </p:txBody>
       </p:sp>
@@ -16223,7 +16223,7 @@
               <a:buNone/>
             </a:pPr>
             <a:r>
-              <a:rPr lang="en-US" sz="1750" b="1" dirty="0">
+              <a:rPr lang="en-US" sz="1850" b="1" dirty="0">
                 <a:solidFill>
                   <a:srgbClr val="002050"/>
                 </a:solidFill>
@@ -16241,7 +16241,7 @@
               <a:buNone/>
             </a:pPr>
             <a:r>
-              <a:rPr lang="en-US" sz="1400" dirty="0">
+              <a:rPr lang="en-US" sz="1500" dirty="0">
                 <a:solidFill>
                   <a:srgbClr val="002050"/>
                 </a:solidFill>
@@ -16251,7 +16251,7 @@
               </a:rPr>
               <a:t>Careful choice of words can enable you to convey many subtleties of meaning.</a:t>
             </a:r>
-            <a:endParaRPr lang="en-US" sz="1750" dirty="0"/>
+            <a:endParaRPr lang="en-US" sz="1850" dirty="0"/>
           </a:p>
         </p:txBody>
       </p:sp>
@@ -16337,7 +16337,7 @@
               <a:buNone/>
             </a:pPr>
             <a:r>
-              <a:rPr lang="en-US" sz="1750" b="1" dirty="0">
+              <a:rPr lang="en-US" sz="1850" b="1" dirty="0">
                 <a:solidFill>
                   <a:srgbClr val="002050"/>
                 </a:solidFill>
@@ -16355,7 +16355,7 @@
               <a:buNone/>
             </a:pPr>
             <a:r>
-              <a:rPr lang="en-US" sz="1400" dirty="0">
+              <a:rPr lang="en-US" sz="1500" dirty="0">
                 <a:solidFill>
                   <a:srgbClr val="002050"/>
                 </a:solidFill>
@@ -16365,7 +16365,7 @@
               </a:rPr>
               <a:t>Check that everything you write is factually accurate and capable of being verified. Arguments should be soundly based and your reasoning logical. Do not write anything that will misinform, mislead or unfairly persuade your readers — accurate information is essential for effective communication and decision making.</a:t>
             </a:r>
-            <a:endParaRPr lang="en-US" sz="1750" dirty="0"/>
+            <a:endParaRPr lang="en-US" sz="1850" dirty="0"/>
           </a:p>
         </p:txBody>
       </p:sp>
@@ -16451,7 +16451,7 @@
               <a:buNone/>
             </a:pPr>
             <a:r>
-              <a:rPr lang="en-US" sz="1750" b="1" dirty="0">
+              <a:rPr lang="en-US" sz="1850" b="1" dirty="0">
                 <a:solidFill>
                   <a:srgbClr val="002050"/>
                 </a:solidFill>
@@ -16469,7 +16469,7 @@
               <a:buNone/>
             </a:pPr>
             <a:r>
-              <a:rPr lang="en-US" sz="1400" dirty="0">
+              <a:rPr lang="en-US" sz="1500" dirty="0">
                 <a:solidFill>
                   <a:srgbClr val="002050"/>
                 </a:solidFill>
@@ -16479,7 +16479,7 @@
               </a:rPr>
               <a:t>A report should not be an essay reflecting personal emotions and opinions. Look at all sides of a problem with an open mind before stating conclusions. Showing an open mind makes your conclusions and recommendations more acceptable — the emphasis is on the factual material and conclusions drawn, not on personal beliefs, biases or prejudices.</a:t>
             </a:r>
-            <a:endParaRPr lang="en-US" sz="1750" dirty="0"/>
+            <a:endParaRPr lang="en-US" sz="1850" dirty="0"/>
           </a:p>
         </p:txBody>
       </p:sp>
@@ -16621,8 +16621,8 @@
         </p:nvSpPr>
         <p:spPr>
           <a:xfrm>
-            <a:off x="502920" y="274320"/>
-            <a:ext cx="11183112" cy="329184"/>
+            <a:off x="502920" y="256032"/>
+            <a:ext cx="11183112" cy="347472"/>
           </a:xfrm>
           <a:prstGeom prst="rect">
             <a:avLst/>
@@ -16638,7 +16638,7 @@
               <a:buNone/>
             </a:pPr>
             <a:r>
-              <a:rPr lang="en-US" sz="1300" b="1" spc="200" kern="0" dirty="0">
+              <a:rPr lang="en-US" sz="1400" b="1" spc="200" kern="0" dirty="0">
                 <a:solidFill>
                   <a:srgbClr val="0F6CBD"/>
                 </a:solidFill>
@@ -16648,7 +16648,7 @@
               </a:rPr>
               <a:t>QUALITIES OF GOOD REPORT WRITING · 2 OF 2</a:t>
             </a:r>
-            <a:endParaRPr lang="en-US" sz="1300" dirty="0"/>
+            <a:endParaRPr lang="en-US" sz="1400" dirty="0"/>
           </a:p>
         </p:txBody>
       </p:sp>
@@ -16660,8 +16660,8 @@
         </p:nvSpPr>
         <p:spPr>
           <a:xfrm>
-            <a:off x="502920" y="603504"/>
-            <a:ext cx="11183112" cy="749808"/>
+            <a:off x="502920" y="585216"/>
+            <a:ext cx="11183112" cy="786384"/>
           </a:xfrm>
           <a:prstGeom prst="rect">
             <a:avLst/>
@@ -16677,7 +16677,7 @@
               <a:buNone/>
             </a:pPr>
             <a:r>
-              <a:rPr lang="en-US" sz="3100" b="1" dirty="0">
+              <a:rPr lang="en-US" sz="3400" b="1" dirty="0">
                 <a:solidFill>
                   <a:srgbClr val="002050"/>
                 </a:solidFill>
@@ -16687,7 +16687,7 @@
               </a:rPr>
               <a:t>The Qualities of Good Report Writing</a:t>
             </a:r>
-            <a:endParaRPr lang="en-US" sz="3100" dirty="0"/>
+            <a:endParaRPr lang="en-US" sz="3400" dirty="0"/>
           </a:p>
         </p:txBody>
       </p:sp>
@@ -16773,7 +16773,7 @@
               <a:buNone/>
             </a:pPr>
             <a:r>
-              <a:rPr lang="en-US" sz="1750" b="1" dirty="0">
+              <a:rPr lang="en-US" sz="1850" b="1" dirty="0">
                 <a:solidFill>
                   <a:srgbClr val="002050"/>
                 </a:solidFill>
@@ -16791,7 +16791,7 @@
               <a:buNone/>
             </a:pPr>
             <a:r>
-              <a:rPr lang="en-US" sz="1400" dirty="0">
+              <a:rPr lang="en-US" sz="1500" dirty="0">
                 <a:solidFill>
                   <a:srgbClr val="002050"/>
                 </a:solidFill>
@@ -16801,7 +16801,7 @@
               </a:rPr>
               <a:t>'Veni, Vidi, Vici' (I came, I saw, I conquered) — that is how Julius Caesar reported his visit. While your reports won't be this short, aim to keep them concise. Do not mistake brevity for conciseness: a brief report may omit important information; a concise report is short but keeps all essential details.</a:t>
             </a:r>
-            <a:endParaRPr lang="en-US" sz="1750" dirty="0"/>
+            <a:endParaRPr lang="en-US" sz="1850" dirty="0"/>
           </a:p>
         </p:txBody>
       </p:sp>
@@ -16887,7 +16887,7 @@
               <a:buNone/>
             </a:pPr>
             <a:r>
-              <a:rPr lang="en-US" sz="1750" b="1" dirty="0">
+              <a:rPr lang="en-US" sz="1850" b="1" dirty="0">
                 <a:solidFill>
                   <a:srgbClr val="002050"/>
                 </a:solidFill>
@@ -16905,7 +16905,7 @@
               <a:buNone/>
             </a:pPr>
             <a:r>
-              <a:rPr lang="en-US" sz="1400" dirty="0">
+              <a:rPr lang="en-US" sz="1500" dirty="0">
                 <a:solidFill>
                   <a:srgbClr val="002050"/>
                 </a:solidFill>
@@ -16915,7 +16915,7 @@
               </a:rPr>
               <a:t>The best way to achieve clarity is to allow time between the first draft and its revision — over a weekend, or at least overnight. If under pressure, at least leave it over a lunch or coffee break. A period of time thinking of other things lets you return with objectivity.</a:t>
             </a:r>
-            <a:endParaRPr lang="en-US" sz="1750" dirty="0"/>
+            <a:endParaRPr lang="en-US" sz="1850" dirty="0"/>
           </a:p>
         </p:txBody>
       </p:sp>
@@ -17001,7 +17001,7 @@
               <a:buNone/>
             </a:pPr>
             <a:r>
-              <a:rPr lang="en-US" sz="1750" b="1" dirty="0">
+              <a:rPr lang="en-US" sz="1850" b="1" dirty="0">
                 <a:solidFill>
                   <a:srgbClr val="002050"/>
                 </a:solidFill>
@@ -17019,7 +17019,7 @@
               <a:buNone/>
             </a:pPr>
             <a:r>
-              <a:rPr lang="en-US" sz="1400" dirty="0">
+              <a:rPr lang="en-US" sz="1500" dirty="0">
                 <a:solidFill>
                   <a:srgbClr val="002050"/>
                 </a:solidFill>
@@ -17029,7 +17029,7 @@
               </a:rPr>
               <a:t>If your writing is selective, accurate, objective, concise, clear and consistent, it will also be as simple as it can be. Guard against over-simplifying to the point of leaving out information the reader needs. Keep the reader in mind and ask whether they can follow the logic of your presentation.</a:t>
             </a:r>
-            <a:endParaRPr lang="en-US" sz="1750" dirty="0"/>
+            <a:endParaRPr lang="en-US" sz="1850" dirty="0"/>
           </a:p>
         </p:txBody>
       </p:sp>
@@ -17171,8 +17171,8 @@
         </p:nvSpPr>
         <p:spPr>
           <a:xfrm>
-            <a:off x="502920" y="274320"/>
-            <a:ext cx="11183112" cy="329184"/>
+            <a:off x="502920" y="256032"/>
+            <a:ext cx="11183112" cy="347472"/>
           </a:xfrm>
           <a:prstGeom prst="rect">
             <a:avLst/>
@@ -17188,7 +17188,7 @@
               <a:buNone/>
             </a:pPr>
             <a:r>
-              <a:rPr lang="en-US" sz="1300" b="1" spc="200" kern="0" dirty="0">
+              <a:rPr lang="en-US" sz="1400" b="1" spc="200" kern="0" dirty="0">
                 <a:solidFill>
                   <a:srgbClr val="0F6CBD"/>
                 </a:solidFill>
@@ -17198,7 +17198,7 @@
               </a:rPr>
               <a:t>WRITING TIPS</a:t>
             </a:r>
-            <a:endParaRPr lang="en-US" sz="1300" dirty="0"/>
+            <a:endParaRPr lang="en-US" sz="1400" dirty="0"/>
           </a:p>
         </p:txBody>
       </p:sp>
@@ -17210,8 +17210,8 @@
         </p:nvSpPr>
         <p:spPr>
           <a:xfrm>
-            <a:off x="502920" y="603504"/>
-            <a:ext cx="11183112" cy="749808"/>
+            <a:off x="502920" y="585216"/>
+            <a:ext cx="11183112" cy="786384"/>
           </a:xfrm>
           <a:prstGeom prst="rect">
             <a:avLst/>
@@ -17227,7 +17227,7 @@
               <a:buNone/>
             </a:pPr>
             <a:r>
-              <a:rPr lang="en-US" sz="3100" b="1" dirty="0">
+              <a:rPr lang="en-US" sz="3400" b="1" dirty="0">
                 <a:solidFill>
                   <a:srgbClr val="002050"/>
                 </a:solidFill>
@@ -17237,7 +17237,7 @@
               </a:rPr>
               <a:t>Avoid Pointless Words</a:t>
             </a:r>
-            <a:endParaRPr lang="en-US" sz="3100" dirty="0"/>
+            <a:endParaRPr lang="en-US" sz="3400" dirty="0"/>
           </a:p>
         </p:txBody>
       </p:sp>
@@ -17272,7 +17272,7 @@
               <a:buNone/>
             </a:pPr>
             <a:r>
-              <a:rPr lang="en-US" sz="1700" dirty="0">
+              <a:rPr lang="en-US" sz="1900" dirty="0">
                 <a:solidFill>
                   <a:srgbClr val="002050"/>
                 </a:solidFill>
@@ -17283,7 +17283,7 @@
               <a:t>Some words and phrases — like 'basically', 'actually', 'undoubtedly', 'each and every one' and 'during the course of our investigation' — keep cropping up in reports. Yet they add nothing to the message and often can be removed without changing the meaning or the tone.
 </a:t>
             </a:r>
-            <a:endParaRPr lang="en-US" sz="1700" dirty="0"/>
+            <a:endParaRPr lang="en-US" sz="1900" dirty="0"/>
           </a:p>
           <a:p>
             <a:pPr indent="0" marL="0">
@@ -17296,7 +17296,7 @@
               <a:buNone/>
             </a:pPr>
             <a:r>
-              <a:rPr lang="en-US" sz="1700" dirty="0">
+              <a:rPr lang="en-US" sz="1900" dirty="0">
                 <a:solidFill>
                   <a:srgbClr val="002050"/>
                 </a:solidFill>
@@ -17306,7 +17306,7 @@
               </a:rPr>
               <a:t>Try leaving them out of your writing. You will find your sentences survive, succeed and may even flourish without them.</a:t>
             </a:r>
-            <a:endParaRPr lang="en-US" sz="1700" dirty="0"/>
+            <a:endParaRPr lang="en-US" sz="1900" dirty="0"/>
           </a:p>
         </p:txBody>
       </p:sp>
@@ -17402,7 +17402,7 @@
               <a:buNone/>
             </a:pPr>
             <a:r>
-              <a:rPr lang="en-US" sz="1250" b="1" spc="150" kern="0" dirty="0">
+              <a:rPr lang="en-US" sz="1350" b="1" spc="150" kern="0" dirty="0">
                 <a:solidFill>
                   <a:srgbClr val="0F6CBD"/>
                 </a:solidFill>
@@ -17419,7 +17419,7 @@
               <a:buNone/>
             </a:pPr>
             <a:r>
-              <a:rPr lang="en-US" sz="1550" dirty="0">
+              <a:rPr lang="en-US" sz="1700" dirty="0">
                 <a:solidFill>
                   <a:srgbClr val="002050"/>
                 </a:solidFill>
@@ -17429,7 +17429,7 @@
               </a:rPr>
               <a:t>Take a paragraph you wrote this week and strike out every filler word. Read it again — the meaning stays, the message gets stronger.</a:t>
             </a:r>
-            <a:endParaRPr lang="en-US" sz="1250" dirty="0"/>
+            <a:endParaRPr lang="en-US" sz="1350" dirty="0"/>
           </a:p>
         </p:txBody>
       </p:sp>

</xml_diff>